<commit_message>
docs: rewrite designer workshop as a casual story
Co-authored-by: Elisha Sam Peter Prabhu <ElishaSamPeterPrabhu@users.noreply.github.com>
</commit_message>
<xml_diff>
--- a/docs/workshop-slides/zero-to-production-vibe-coder.pptx
+++ b/docs/workshop-slides/zero-to-production-vibe-coder.pptx
@@ -552,7 +552,7 @@
           <a:p>
             <a:r>
               <a:rPr lang="en-US" dirty="0"/>
-              <a:t>Welcome the room. Make the boundary explicit: nobody needs to read or write code. They will speak to Agent, inspect a running interface, and use design judgment to direct the next change.</a:t>
+              <a:t>Welcome everyone and explain the plan in plain terms. We are going to describe an interface, see what Agent makes, and improve it by looking at the result. Nobody needs to read or write code during the workshop.</a:t>
             </a:r>
             <a:endParaRPr lang="en-US" dirty="0"/>
           </a:p>
@@ -640,7 +640,7 @@
           <a:p>
             <a:r>
               <a:rPr lang="en-US" dirty="0"/>
-              <a:t>Progressive frame two. Explain that HTML describes what things are. Designers do not need to author tags.</a:t>
+              <a:t>Explain HTML as the description of what each part is. Participants only need this mental model so they can ask Agent for a properly organized page.</a:t>
             </a:r>
             <a:endParaRPr lang="en-US" dirty="0"/>
           </a:p>
@@ -728,7 +728,7 @@
           <a:p>
             <a:r>
               <a:rPr lang="en-US" dirty="0"/>
-              <a:t>Progressive frame three. This is the visual “animation” in PowerPoint/Google Slides. Advance between slides slowly.</a:t>
+              <a:t>Advance from the HTML structure slide to this one and point out what changed visually. The purpose stayed the same; the presentation became clearer.</a:t>
             </a:r>
             <a:endParaRPr lang="en-US" dirty="0"/>
           </a:p>
@@ -816,7 +816,7 @@
           <a:p>
             <a:r>
               <a:rPr lang="en-US" dirty="0"/>
-              <a:t>The audience only needs this functional mental model. Avoid syntax, tags, selectors, and file anatomy.</a:t>
+              <a:t>Keep the explanation at this level. The group should understand what to ask for, not how to write HTML tags or CSS selectors.</a:t>
             </a:r>
             <a:endParaRPr lang="en-US" dirty="0"/>
           </a:p>
@@ -904,7 +904,7 @@
           <a:p>
             <a:r>
               <a:rPr lang="en-US" dirty="0"/>
-              <a:t>Give 25–30 minutes. If someone freezes, ask: “What should one person be able to do on the first screen?” Do not give them a login mock.</a:t>
+              <a:t>Give 25–30 minutes. If someone gets stuck, ask what one person should be able to do on the first screen. Help them narrow the goal instead of giving them a screen to copy.</a:t>
             </a:r>
             <a:endParaRPr lang="en-US" dirty="0"/>
           </a:p>
@@ -992,7 +992,7 @@
           <a:p>
             <a:r>
               <a:rPr lang="en-US" dirty="0"/>
-              <a:t>Use self-check, peer glance, facilitator gate, then Q&amp;A. Score the running design and process—not code.</a:t>
+              <a:t>Keep this low pressure. Check whether each person can create, inspect, and revise a page. Do not discuss the generated code.</a:t>
             </a:r>
             <a:endParaRPr lang="en-US" dirty="0"/>
           </a:p>
@@ -1080,7 +1080,7 @@
           <a:p>
             <a:r>
               <a:rPr lang="en-US" dirty="0"/>
-              <a:t>Allow anonymous questions. Recurring questions become a 3-minute live micro-demo.</a:t>
+              <a:t>Take blocked and basic questions first. After each answer, briefly state how the same approach could help in another situation.</a:t>
             </a:r>
             <a:endParaRPr lang="en-US" dirty="0"/>
           </a:p>
@@ -1168,7 +1168,7 @@
           <a:p>
             <a:r>
               <a:rPr lang="en-US" dirty="0"/>
-              <a:t>Apply everything to the interface each participant already created.</a:t>
+              <a:t>Keep working with the page each person already made. We are going to add behavior, not start a second exercise.</a:t>
             </a:r>
             <a:endParaRPr lang="en-US" dirty="0"/>
           </a:p>
@@ -1256,7 +1256,7 @@
           <a:p>
             <a:r>
               <a:rPr lang="en-US" dirty="0"/>
-              <a:t>Connect this to Figma frames. Several frames may document states, but implementation is one product whose memory changes.</a:t>
+              <a:t>Connect this to Figma. Separate frames can document open, closed, empty, or error states. In the working interface, those moments belong to the same product.</a:t>
             </a:r>
             <a:endParaRPr lang="en-US" dirty="0"/>
           </a:p>
@@ -1344,7 +1344,7 @@
           <a:p>
             <a:r>
               <a:rPr lang="en-US" dirty="0"/>
-              <a:t>Avoid teaching framework internals. They only need to understand why Agent needs a vehicle beyond static HTML/CSS.</a:t>
+              <a:t>Do not explain framework internals. Explain the practical reason: once the interface needs behavior and repeated parts, Agent needs a framework target.</a:t>
             </a:r>
             <a:endParaRPr lang="en-US" dirty="0"/>
           </a:p>
@@ -1432,7 +1432,7 @@
           <a:p>
             <a:r>
               <a:rPr lang="en-US" dirty="0"/>
-              <a:t>The wording matters: we are not training React developers. We are giving Agent a consistent target.</a:t>
+              <a:t>Make it clear that participants are not learning React syntax. They only need to know why Agent is using it and that Angular or Vue may be the right choice in another product.</a:t>
             </a:r>
             <a:endParaRPr lang="en-US" dirty="0"/>
           </a:p>
@@ -1520,7 +1520,7 @@
           <a:p>
             <a:r>
               <a:rPr lang="en-US" dirty="0"/>
-              <a:t>Build confidence without overpromising. AI does not replace their judgment. It makes their decisions executable and testable.</a:t>
+              <a:t>Do not begin with theory. Set up the first experiment: describe something small, run it, and inspect it. The useful skill is learning how to notice the gap between what we meant and what Agent produced.</a:t>
             </a:r>
             <a:endParaRPr lang="en-US" dirty="0"/>
           </a:p>
@@ -1608,7 +1608,7 @@
           <a:p>
             <a:r>
               <a:rPr lang="en-US" dirty="0"/>
-              <a:t>Progressive state frame one. Use the iPad/Figma only if it makes the open/closed concept easier.</a:t>
+              <a:t>Show the closed state first. Ask the group what information the interface must keep track of. Use Figma on the iPad only if the visual comparison helps.</a:t>
             </a:r>
             <a:endParaRPr lang="en-US" dirty="0"/>
           </a:p>
@@ -1696,7 +1696,7 @@
           <a:p>
             <a:r>
               <a:rPr lang="en-US" dirty="0"/>
-              <a:t>Progressive state frame two. There is no need to show useState or any code.</a:t>
+              <a:t>Advance to the open state. The group only needs to understand the behavior; do not show a hook or generated code.</a:t>
             </a:r>
             <a:endParaRPr lang="en-US" dirty="0"/>
           </a:p>
@@ -1784,7 +1784,7 @@
           <a:p>
             <a:r>
               <a:rPr lang="en-US" dirty="0"/>
-              <a:t>This state checklist becomes a persistent quality tool through the rest of the workshop.</a:t>
+              <a:t>Use these six moments as a checklist. Not every feature needs all six, but Agent should not build only the final happy state.</a:t>
             </a:r>
             <a:endParaRPr lang="en-US" dirty="0"/>
           </a:p>
@@ -1872,7 +1872,7 @@
           <a:p>
             <a:r>
               <a:rPr lang="en-US" dirty="0"/>
-              <a:t>Give 25–30 minutes. Support is faded: they now fill in more of the prompt themselves.</a:t>
+              <a:t>Give 25–30 minutes. Participants should now decide more of the request themselves. Ask them to choose one useful behavior rather than adding several features.</a:t>
             </a:r>
             <a:endParaRPr lang="en-US" dirty="0"/>
           </a:p>
@@ -1960,7 +1960,7 @@
           <a:p>
             <a:r>
               <a:rPr lang="en-US" dirty="0"/>
-              <a:t>Assessment is visual and behavioral. No one needs to identify a hook or read generated code.</a:t>
+              <a:t>Keep the check visual and behavioral. Nobody needs to identify React code or explain how Agent implemented it.</a:t>
             </a:r>
             <a:endParaRPr lang="en-US" dirty="0"/>
           </a:p>
@@ -2048,7 +2048,7 @@
           <a:p>
             <a:r>
               <a:rPr lang="en-US" dirty="0"/>
-              <a:t>Use retrieval: ask a participant to explain state without using technical terminology.</a:t>
+              <a:t>Ask one participant to explain state in everyday language. Resolve framework questions, then move into setup and context.</a:t>
             </a:r>
             <a:endParaRPr lang="en-US" dirty="0"/>
           </a:p>
@@ -2136,7 +2136,7 @@
           <a:p>
             <a:r>
               <a:rPr lang="en-US" dirty="0"/>
-              <a:t>This is the major independence gate. Participants install context rather than relying on a generic model.</a:t>
+              <a:t>This is the first full assessment. Participants will connect Agent to Modus and Figma instead of relying on general knowledge.</a:t>
             </a:r>
             <a:endParaRPr lang="en-US" dirty="0"/>
           </a:p>
@@ -2224,7 +2224,7 @@
           <a:p>
             <a:r>
               <a:rPr lang="en-US" dirty="0"/>
-              <a:t>Use an animated analogy: guardrails, recipes, connected tools. This is conceptual; the official one-step setup handles installation.</a:t>
+              <a:t>Explain each item through what it helps Agent do. The setup page will handle installation, so participants do not need to learn configuration files.</a:t>
             </a:r>
             <a:endParaRPr lang="en-US" dirty="0"/>
           </a:p>
@@ -2312,7 +2312,7 @@
           <a:p>
             <a:r>
               <a:rPr lang="en-US" dirty="0"/>
-              <a:t>Open the live setup route. Participants paste the official setup prompt into Agent. Do not make novices hand-edit configuration files.</a:t>
+              <a:t>Open the live setup route and let participants paste the official prompt into Agent. Avoid showing or explaining the underlying configuration files.</a:t>
             </a:r>
             <a:endParaRPr lang="en-US" dirty="0"/>
           </a:p>
@@ -2400,7 +2400,7 @@
           <a:p>
             <a:r>
               <a:rPr lang="en-US" dirty="0"/>
-              <a:t>Show the live Modus Cursor Rules page. Explain the concept, not the .mdc syntax.</a:t>
+              <a:t>Show the live Rules page. Explain that rules keep Agent from changing direction every time. Do not discuss .mdc syntax.</a:t>
             </a:r>
             <a:endParaRPr lang="en-US" dirty="0"/>
           </a:p>
@@ -2488,7 +2488,7 @@
           <a:p>
             <a:r>
               <a:rPr lang="en-US" dirty="0"/>
-              <a:t>Use this boundary throughout. “Production quality” here means a credible, testable frontend prototype—not independently certified production software.</a:t>
+              <a:t>Explain the boundary without making it sound like a handoff wall. Designers will produce a useful, testable frontend prototype. Engineering still reviews and connects the parts that involve real data, security, performance, and production architecture.</a:t>
             </a:r>
             <a:endParaRPr lang="en-US" dirty="0"/>
           </a:p>
@@ -2576,7 +2576,7 @@
           <a:p>
             <a:r>
               <a:rPr lang="en-US" dirty="0"/>
-              <a:t>Show the live Modus Cursor Skills page. Agent chooses relevant skills; designers need not invoke every file by name.</a:t>
+              <a:t>Show the live Skills page. Point out a few practical examples. Designers do not need to remember file names or manually choose every skill.</a:t>
             </a:r>
             <a:endParaRPr lang="en-US" dirty="0"/>
           </a:p>
@@ -2664,7 +2664,7 @@
           <a:p>
             <a:r>
               <a:rPr lang="en-US" dirty="0"/>
-              <a:t>MCP is not “more intelligence.” It is access. Keep databases and secret managers out of this workshop.</a:t>
+              <a:t>Explain MCP as a connection, not a smarter model. It can bring in current Modus documentation or a Figma selection. Leave databases and secret management out of this workshop.</a:t>
             </a:r>
             <a:endParaRPr lang="en-US" dirty="0"/>
           </a:p>
@@ -2752,7 +2752,7 @@
           <a:p>
             <a:r>
               <a:rPr lang="en-US" dirty="0"/>
-              <a:t>Correct terminology: Figma provides the Cursor plugin; Modus provides synchronized Figma libraries and implementation tooling. There is no verified standalone Modus Figma plugin.</a:t>
+              <a:t>Clarify the setup: Figma provides the Cursor plugin. Modus provides the Figma libraries and implementation guidance. There is no separate Modus Figma plugin to install.</a:t>
             </a:r>
             <a:endParaRPr lang="en-US" dirty="0"/>
           </a:p>
@@ -2840,7 +2840,7 @@
           <a:p>
             <a:r>
               <a:rPr lang="en-US" dirty="0"/>
-              <a:t>This is awareness, not an installation race. Install only what the product team actually uses.</a:t>
+              <a:t>Treat this as a quick tour. The goal is not to install everything. Connect only the tools that hold information the team actually needs.</a:t>
             </a:r>
             <a:endParaRPr lang="en-US" dirty="0"/>
           </a:p>
@@ -2928,7 +2928,7 @@
           <a:p>
             <a:r>
               <a:rPr lang="en-US" dirty="0"/>
-              <a:t>Give 60–75 minutes. Use the participant’s Figma work; golden Modus file is the recovery option. Follow with Q&amp;A and Day-1 reflection.</a:t>
+              <a:t>Give 60–75 minutes. Participants should use their own Figma work. Keep the golden Modus file available only as a recovery option.</a:t>
             </a:r>
             <a:endParaRPr lang="en-US" dirty="0"/>
           </a:p>
@@ -3016,7 +3016,7 @@
           <a:p>
             <a:r>
               <a:rPr lang="en-US" dirty="0"/>
-              <a:t>Collect a one-sentence reflection: “The most important change I made to my process was…”</a:t>
+              <a:t>Collect one short reflection from each person: what changed in the way they described, checked, or corrected the work?</a:t>
             </a:r>
             <a:endParaRPr lang="en-US" dirty="0"/>
           </a:p>
@@ -3104,7 +3104,7 @@
           <a:p>
             <a:r>
               <a:rPr lang="en-US" dirty="0"/>
-              <a:t>Start with spaced retrieval: participants reconstruct the operating loop and brain from memory before showing the reference.</a:t>
+              <a:t>Before showing the reference, ask participants to recall the workflow and the context they connected on Day 1.</a:t>
             </a:r>
             <a:endParaRPr lang="en-US" dirty="0"/>
           </a:p>
@@ -3192,7 +3192,7 @@
           <a:p>
             <a:r>
               <a:rPr lang="en-US" dirty="0"/>
-              <a:t>Tour the live site map. Teach where to look—not the contents of every page.</a:t>
+              <a:t>Give a short tour of where to find foundations, components, patterns, templates, Figma libraries, and AI setup. Teach where to look instead of opening every page.</a:t>
             </a:r>
             <a:endParaRPr lang="en-US" dirty="0"/>
           </a:p>
@@ -3280,7 +3280,7 @@
           <a:p>
             <a:r>
               <a:rPr lang="en-US" dirty="0"/>
-              <a:t>Reference the synchronized Atomic Design System, Palette, Icons, and Blueprint Figma files.</a:t>
+              <a:t>Reference the Atomic Design System, Palette, Icons, and Blueprint Figma files. Explain that this reduces rework and keeps the prototype close to what engineering can use.</a:t>
             </a:r>
             <a:endParaRPr lang="en-US" dirty="0"/>
           </a:p>
@@ -3368,7 +3368,7 @@
           <a:p>
             <a:r>
               <a:rPr lang="en-US" dirty="0"/>
-              <a:t>Phrase accessibility carefully: Modus is designed for accessibility, but every generated experience still needs verification.</a:t>
+              <a:t>Walk through the checks in practical terms. Modus is designed with accessibility in mind, but every generated experience still needs to be tested.</a:t>
             </a:r>
             <a:endParaRPr lang="en-US" dirty="0"/>
           </a:p>
@@ -3456,7 +3456,7 @@
           <a:p>
             <a:r>
               <a:rPr lang="en-US" dirty="0"/>
-              <a:t>Ask participants to predict the next step before revealing it. This loop is the one reusable behavior across all phases.</a:t>
+              <a:t>Walk through the loop once, then ask the group what they would do after seeing an imperfect first result. Keep returning to this sequence during assessments.</a:t>
             </a:r>
             <a:endParaRPr lang="en-US" dirty="0"/>
           </a:p>
@@ -3544,7 +3544,7 @@
           <a:p>
             <a:r>
               <a:rPr lang="en-US" dirty="0"/>
-              <a:t>Never accept “tests pass” from Agent without observing the UI. Agent can silently regress previous behavior.</a:t>
+              <a:t>Do not rely on a message saying the tests passed. Ask participants to watch the behavior themselves and check earlier interactions after each meaningful change.</a:t>
             </a:r>
             <a:endParaRPr lang="en-US" dirty="0"/>
           </a:p>
@@ -3632,7 +3632,7 @@
           <a:p>
             <a:r>
               <a:rPr lang="en-US" dirty="0"/>
-              <a:t>Use the seeded flawed app: missing empty state, narrow-layout break, focus issue, long content overflow, or fabricated connected data.</a:t>
+              <a:t>Use the prepared flawed app: missing empty state, narrow-layout issue, focus problem, long-content overflow, fabricated connected data, or a regression.</a:t>
             </a:r>
             <a:endParaRPr lang="en-US" dirty="0"/>
           </a:p>
@@ -3720,7 +3720,7 @@
           <a:p>
             <a:r>
               <a:rPr lang="en-US" dirty="0"/>
-              <a:t>Require at least “Ready” or “Ready with support” for functional states, accessibility, safety, and handoff.</a:t>
+              <a:t>Require a working result or a working result with a small amount of help. Pay special attention to states, accessibility, safe assumptions, and handoff.</a:t>
             </a:r>
             <a:endParaRPr lang="en-US" dirty="0"/>
           </a:p>
@@ -3808,7 +3808,7 @@
           <a:p>
             <a:r>
               <a:rPr lang="en-US" dirty="0"/>
-              <a:t>Keep answers tied to observable evidence in Browser and references in the Modus Blueprint.</a:t>
+              <a:t>Keep answers grounded in what participants can see in Preview or confirm in the Modus site.</a:t>
             </a:r>
             <a:endParaRPr lang="en-US" dirty="0"/>
           </a:p>
@@ -3896,7 +3896,7 @@
           <a:p>
             <a:r>
               <a:rPr lang="en-US" dirty="0"/>
-              <a:t>This is delivery literacy, not DevOps. Avoid secrets, environment variables, CI, and production infrastructure.</a:t>
+              <a:t>Keep this practical. Participants need to publish and share a prototype, not learn DevOps or production infrastructure.</a:t>
             </a:r>
             <a:endParaRPr lang="en-US" dirty="0"/>
           </a:p>
@@ -3984,7 +3984,7 @@
           <a:p>
             <a:r>
               <a:rPr lang="en-US" dirty="0"/>
-              <a:t>Use Cursor Source Control or Agent to perform the steps. They do not need to read a diff or use terminal Git.</a:t>
+              <a:t>Use Cursor Source Control or Agent for these steps. Participants do not need terminal Git or a diff walkthrough.</a:t>
             </a:r>
             <a:endParaRPr lang="en-US" dirty="0"/>
           </a:p>
@@ -4072,7 +4072,7 @@
           <a:p>
             <a:r>
               <a:rPr lang="en-US" dirty="0"/>
-              <a:t>A teammate can view a shared Cursor Agent run only if they also have access to the repository.</a:t>
+              <a:t>Explain that sharing a Cursor Agent run does not automatically share the repository. The other person still needs the correct repository access.</a:t>
             </a:r>
             <a:endParaRPr lang="en-US" dirty="0"/>
           </a:p>
@@ -4160,7 +4160,7 @@
           <a:p>
             <a:r>
               <a:rPr lang="en-US" dirty="0"/>
-              <a:t>Have a peer or facilitator open the links on a different account/device. Do not accept localhost.</a:t>
+              <a:t>Have someone else open the links from a different account or device. A localhost link does not count as shared.</a:t>
             </a:r>
             <a:endParaRPr lang="en-US" dirty="0"/>
           </a:p>
@@ -4248,7 +4248,7 @@
           <a:p>
             <a:r>
               <a:rPr lang="en-US" dirty="0"/>
-              <a:t>Do not average away a critical failure. Use the rubric for the workshop and the 45-day peer review.</a:t>
+              <a:t>Explain that a polished look cannot make up for a broken flow, unsafe assumption, inaccessible interaction, or missing handoff.</a:t>
             </a:r>
             <a:endParaRPr lang="en-US" dirty="0"/>
           </a:p>
@@ -4336,7 +4336,7 @@
           <a:p>
             <a:r>
               <a:rPr lang="en-US" dirty="0"/>
-              <a:t>Facilitator responds with one “keep” and one “improve,” not a code review.</a:t>
+              <a:t>Respond with one thing to keep and one thing to improve. This is a product and workflow review, not a code review.</a:t>
             </a:r>
             <a:endParaRPr lang="en-US" dirty="0"/>
           </a:p>
@@ -4424,7 +4424,7 @@
           <a:p>
             <a:r>
               <a:rPr lang="en-US" dirty="0"/>
-              <a:t>Every phase ends with an assessment and Q&amp;A. The first two are small. Phase 3 is the first large independence gate.</a:t>
+              <a:t>Set expectations for the rhythm: short explanation, hands-on work, a quick check, and questions. The first full assessment comes after the setup and context phase.</a:t>
             </a:r>
             <a:endParaRPr lang="en-US" dirty="0"/>
           </a:p>
@@ -4512,7 +4512,7 @@
           <a:p>
             <a:r>
               <a:rPr lang="en-US" dirty="0"/>
-              <a:t>Ask managers to assign a real, low-risk prototype within two weeks. Store Agent conversations, failures, and evidence—not only screenshots.</a:t>
+              <a:t>Ask managers to assign a real, low-risk prototype within two weeks. Keep useful Agent conversations and examples of what failed and improved—not only final screenshots.</a:t>
             </a:r>
             <a:endParaRPr lang="en-US" dirty="0"/>
           </a:p>
@@ -4600,7 +4600,7 @@
           <a:p>
             <a:r>
               <a:rPr lang="en-US" dirty="0"/>
-              <a:t>End with Q&amp;A. Re-state the boundary: Agent implements; designers direct and verify; engineering productionizes.</a:t>
+              <a:t>End with open questions. Remind the group that Agent can implement quickly, but people still need to describe the goal, check the behavior, and decide whether the result is good enough to share.</a:t>
             </a:r>
             <a:endParaRPr lang="en-US" dirty="0"/>
           </a:p>
@@ -4688,7 +4688,7 @@
           <a:p>
             <a:r>
               <a:rPr lang="en-US" dirty="0"/>
-              <a:t>Start from true zero. Avoid technical vocabulary until it solves a visible design problem.</a:t>
+              <a:t>Start with the result they can see. Introduce HTML and CSS only after the first page gives those terms a practical purpose.</a:t>
             </a:r>
             <a:endParaRPr lang="en-US" dirty="0"/>
           </a:p>
@@ -4776,7 +4776,7 @@
           <a:p>
             <a:r>
               <a:rPr lang="en-US" dirty="0"/>
-              <a:t>Keep participants in the Agent window and browser preview. Do not use Cmd+K, the file explorer, or code as teaching surfaces.</a:t>
+              <a:t>Keep the group in Agent and Preview. The point is not to accept the first result. The point is to learn how to turn a visual observation into the next useful request.</a:t>
             </a:r>
             <a:endParaRPr lang="en-US" dirty="0"/>
           </a:p>
@@ -4864,7 +4864,7 @@
           <a:p>
             <a:r>
               <a:rPr lang="en-US" dirty="0"/>
-              <a:t>Show the two-pane layout: Agent and preview. If participants see code, tell them it is implementation detail—not their work surface.</a:t>
+              <a:t>Show the two-pane setup. Agent is where they describe the work. Preview is where they decide whether it works. If code appears, reassure them that they do not need to read it.</a:t>
             </a:r>
             <a:endParaRPr lang="en-US" dirty="0"/>
           </a:p>
@@ -4952,7 +4952,7 @@
           <a:p>
             <a:r>
               <a:rPr lang="en-US" dirty="0"/>
-              <a:t>This is progressive frame one. Show anonymous boxes only. Do not show code or a finished product example.</a:t>
+              <a:t>Use the anonymous boxes to explain that a page begins with organization. Do not introduce tags or show source code.</a:t>
             </a:r>
             <a:endParaRPr lang="en-US" dirty="0"/>
           </a:p>
@@ -5644,7 +5644,7 @@
                 <a:ea typeface="Arial" pitchFamily="34" charset="-122"/>
                 <a:cs typeface="Arial" pitchFamily="34" charset="-120"/>
               </a:rPr>
-              <a:t>Zero to production-quality vibe coder</a:t>
+              <a:t>From an idea to a working prototype</a:t>
             </a:r>
             <a:endParaRPr lang="en-US" sz="4400" dirty="0"/>
           </a:p>
@@ -5685,7 +5685,7 @@
                 <a:ea typeface="Arial" pitchFamily="34" charset="-122"/>
                 <a:cs typeface="Arial" pitchFamily="34" charset="-120"/>
               </a:rPr>
-              <a:t>English + design → Agent → Modus → a live product prototype</a:t>
+              <a:t>We’ll start with a simple page, improve it step by step, and finish with something others can open and try.</a:t>
             </a:r>
             <a:endParaRPr lang="en-US" sz="2200" dirty="0"/>
           </a:p>
@@ -5726,7 +5726,7 @@
                 <a:ea typeface="Arial" pitchFamily="34" charset="-122"/>
                 <a:cs typeface="Arial" pitchFamily="34" charset="-120"/>
               </a:rPr>
-              <a:t>Two-day workshop · Agent window only</a:t>
+              <a:t>Two-day workshop · Cursor Agent + Modus</a:t>
             </a:r>
             <a:endParaRPr lang="en-US" sz="1300" dirty="0"/>
           </a:p>
@@ -5885,7 +5885,7 @@
                 <a:ea typeface="Arial" pitchFamily="34" charset="-122"/>
                 <a:cs typeface="Arial" pitchFamily="34" charset="-120"/>
               </a:rPr>
-              <a:t>HTML gives structure meaning.</a:t>
+              <a:t>HTML gives each part a purpose.</a:t>
             </a:r>
             <a:endParaRPr lang="en-US" sz="3100" dirty="0"/>
           </a:p>
@@ -6161,7 +6161,7 @@
                 <a:ea typeface="Arial" pitchFamily="34" charset="-122"/>
                 <a:cs typeface="Arial" pitchFamily="34" charset="-120"/>
               </a:rPr>
-              <a:t>A heading, controls, content, and actions become understandable regions.</a:t>
+              <a:t>It tells the browser which part is a heading, a control, a section of content, or an action.</a:t>
             </a:r>
             <a:endParaRPr lang="en-US" sz="1400" dirty="0"/>
           </a:p>
@@ -6320,7 +6320,7 @@
                 <a:ea typeface="Arial" pitchFamily="34" charset="-122"/>
                 <a:cs typeface="Arial" pitchFamily="34" charset="-120"/>
               </a:rPr>
-              <a:t>CSS gives the structure art direction.</a:t>
+              <a:t>Then CSS controls how it looks.</a:t>
             </a:r>
             <a:endParaRPr lang="en-US" sz="3100" dirty="0"/>
           </a:p>
@@ -6683,7 +6683,7 @@
                 <a:ea typeface="Arial" pitchFamily="34" charset="-122"/>
                 <a:cs typeface="Arial" pitchFamily="34" charset="-120"/>
               </a:rPr>
-              <a:t>Type, spacing, color, scale, and alignment create hierarchy—without changing the underlying purpose.</a:t>
+              <a:t>Type, spacing, color, scale, and alignment make the same structure easier to understand and use.</a:t>
             </a:r>
             <a:endParaRPr lang="en-US" sz="1400" dirty="0"/>
           </a:p>
@@ -6842,7 +6842,7 @@
                 <a:ea typeface="Arial" pitchFamily="34" charset="-122"/>
                 <a:cs typeface="Arial" pitchFamily="34" charset="-120"/>
               </a:rPr>
-              <a:t>Structure and look solve different problems.</a:t>
+              <a:t>HTML is structure. CSS is presentation.</a:t>
             </a:r>
             <a:endParaRPr lang="en-US" sz="3100" dirty="0"/>
           </a:p>
@@ -7445,7 +7445,7 @@
                 <a:ea typeface="Arial" pitchFamily="34" charset="-122"/>
                 <a:cs typeface="Arial" pitchFamily="34" charset="-120"/>
               </a:rPr>
-              <a:t>Creative lab: make a small interface you want to exist.</a:t>
+              <a:t>Your turn: make one small page.</a:t>
             </a:r>
             <a:endParaRPr lang="en-US" sz="3100" dirty="0"/>
           </a:p>
@@ -7513,7 +7513,7 @@
                 <a:ea typeface="Arial" pitchFamily="34" charset="-122"/>
                 <a:cs typeface="Arial" pitchFamily="34" charset="-120"/>
               </a:rPr>
-              <a:t>PROMPT IN AGENT</a:t>
+              <a:t>TRY THIS IN AGENT</a:t>
             </a:r>
             <a:endParaRPr lang="en-US" sz="1100" dirty="0"/>
           </a:p>
@@ -7554,7 +7554,7 @@
                 <a:ea typeface="Arial" pitchFamily="34" charset="-122"/>
                 <a:cs typeface="Arial" pitchFamily="34" charset="-120"/>
               </a:rPr>
-              <a:t>Build a small front-end page for [a user] who needs to [achieve a goal]. Include [the minimum things they need]. Create the HTML and CSS, run it, and open it in the browser preview.</a:t>
+              <a:t>Create a simple front-end page for [who it is for]. They need to [what they are trying to do]. Include only [the few things they need first]. Use HTML and CSS, run it, and show me the page in Preview.</a:t>
             </a:r>
             <a:endParaRPr lang="en-US" sz="2100" dirty="0"/>
           </a:p>
@@ -7595,7 +7595,7 @@
                 <a:ea typeface="Arial" pitchFamily="34" charset="-122"/>
                 <a:cs typeface="Arial" pitchFamily="34" charset="-120"/>
               </a:rPr>
-              <a:t>No specimen. No expected visual. Start with a real design problem.</a:t>
+              <a:t>Use a real idea. Keep the first version small enough to finish and discuss.</a:t>
             </a:r>
             <a:endParaRPr lang="en-US" sz="1400" dirty="0"/>
           </a:p>
@@ -7754,7 +7754,7 @@
                 <a:ea typeface="Arial" pitchFamily="34" charset="-122"/>
                 <a:cs typeface="Arial" pitchFamily="34" charset="-120"/>
               </a:rPr>
-              <a:t>Phase 1 assessment</a:t>
+              <a:t>Quick check before we move on</a:t>
             </a:r>
             <a:endParaRPr lang="en-US" sz="3100" dirty="0"/>
           </a:p>
@@ -7865,7 +7865,7 @@
                 <a:ea typeface="Arial" pitchFamily="34" charset="-122"/>
                 <a:cs typeface="Arial" pitchFamily="34" charset="-120"/>
               </a:rPr>
-              <a:t>A page is running in Preview</a:t>
+              <a:t>The page is open in Preview</a:t>
             </a:r>
             <a:endParaRPr lang="en-US" sz="1450" dirty="0"/>
           </a:p>
@@ -7976,7 +7976,7 @@
                 <a:ea typeface="Arial" pitchFamily="34" charset="-122"/>
                 <a:cs typeface="Arial" pitchFamily="34" charset="-120"/>
               </a:rPr>
-              <a:t>The participant can explain the user goal</a:t>
+              <a:t>You can explain who it is for and what they need to do</a:t>
             </a:r>
             <a:endParaRPr lang="en-US" sz="1450" dirty="0"/>
           </a:p>
@@ -8087,7 +8087,7 @@
                 <a:ea typeface="Arial" pitchFamily="34" charset="-122"/>
                 <a:cs typeface="Arial" pitchFamily="34" charset="-120"/>
               </a:rPr>
-              <a:t>They made one revision through Agent</a:t>
+              <a:t>You asked Agent for one clear improvement</a:t>
             </a:r>
             <a:endParaRPr lang="en-US" sz="1450" dirty="0"/>
           </a:p>
@@ -8198,7 +8198,7 @@
                 <a:ea typeface="Arial" pitchFamily="34" charset="-122"/>
                 <a:cs typeface="Arial" pitchFamily="34" charset="-120"/>
               </a:rPr>
-              <a:t>They can restore a Checkpoint if needed</a:t>
+              <a:t>You know how to return to a Checkpoint</a:t>
             </a:r>
             <a:endParaRPr lang="en-US" sz="1450" dirty="0"/>
           </a:p>
@@ -8239,7 +8239,7 @@
                 <a:ea typeface="Arial" pitchFamily="34" charset="-122"/>
                 <a:cs typeface="Arial" pitchFamily="34" charset="-120"/>
               </a:rPr>
-              <a:t>Gate: Ready · Ready with support · Not yet</a:t>
+              <a:t>Ready · Ready with a little help · Let’s fix this together</a:t>
             </a:r>
             <a:endParaRPr lang="en-US" sz="1400" dirty="0"/>
           </a:p>
@@ -8398,7 +8398,7 @@
                 <a:ea typeface="Arial" pitchFamily="34" charset="-122"/>
                 <a:cs typeface="Arial" pitchFamily="34" charset="-120"/>
               </a:rPr>
-              <a:t>Q&amp;A clinic</a:t>
+              <a:t>Questions before we add interaction?</a:t>
             </a:r>
             <a:endParaRPr lang="en-US" sz="3100" dirty="0"/>
           </a:p>
@@ -8789,7 +8789,7 @@
                 <a:ea typeface="Arial" pitchFamily="34" charset="-122"/>
                 <a:cs typeface="Arial" pitchFamily="34" charset="-120"/>
               </a:rPr>
-              <a:t>Close every answer with: “What pattern generalizes?”</a:t>
+              <a:t>If several people hit the same issue, show one short fix to the whole room.</a:t>
             </a:r>
             <a:endParaRPr lang="en-US" sz="1400" dirty="0"/>
           </a:p>
@@ -9045,7 +9045,7 @@
                 <a:ea typeface="Arial" pitchFamily="34" charset="-122"/>
                 <a:cs typeface="Arial" pitchFamily="34" charset="-120"/>
               </a:rPr>
-              <a:t>Why frameworks exist—and just enough state</a:t>
+              <a:t>From a page to something people can use</a:t>
             </a:r>
             <a:endParaRPr lang="en-US" sz="2400" dirty="0"/>
           </a:p>
@@ -9245,7 +9245,7 @@
                 <a:ea typeface="Arial" pitchFamily="34" charset="-122"/>
                 <a:cs typeface="Arial" pitchFamily="34" charset="-120"/>
               </a:rPr>
-              <a:t>A poster can look finished. A product must remember.</a:t>
+              <a:t>A screenshot shows one moment. A product changes.</a:t>
             </a:r>
             <a:endParaRPr lang="en-US" sz="3100" dirty="0"/>
           </a:p>
@@ -9537,7 +9537,7 @@
                 <a:ea typeface="Arial" pitchFamily="34" charset="-122"/>
                 <a:cs typeface="Arial" pitchFamily="34" charset="-120"/>
               </a:rPr>
-              <a:t>Living interface</a:t>
+              <a:t>Interactive product</a:t>
             </a:r>
             <a:endParaRPr lang="en-US" sz="1700" dirty="0"/>
           </a:p>
@@ -9578,7 +9578,7 @@
                 <a:ea typeface="Arial" pitchFamily="34" charset="-122"/>
                 <a:cs typeface="Arial" pitchFamily="34" charset="-120"/>
               </a:rPr>
-              <a:t>One UI with memory</a:t>
+              <a:t>One interface that changes</a:t>
             </a:r>
             <a:endParaRPr lang="en-US" sz="1250" dirty="0"/>
           </a:p>
@@ -9737,7 +9737,7 @@
                 <a:ea typeface="Arial" pitchFamily="34" charset="-122"/>
                 <a:cs typeface="Arial" pitchFamily="34" charset="-120"/>
               </a:rPr>
-              <a:t>A framework is reusable blocks + a living screen.</a:t>
+              <a:t>Why do we need a framework?</a:t>
             </a:r>
             <a:endParaRPr lang="en-US" sz="3100" dirty="0"/>
           </a:p>
@@ -9778,7 +9778,7 @@
                 <a:ea typeface="Arial" pitchFamily="34" charset="-122"/>
                 <a:cs typeface="Arial" pitchFamily="34" charset="-120"/>
               </a:rPr>
-              <a:t>It helps one interface respond, remember, and reuse.</a:t>
+              <a:t>It helps Agent build parts we can reuse and an interface that can change.</a:t>
             </a:r>
             <a:endParaRPr lang="en-US" sz="3800" dirty="0"/>
           </a:p>
@@ -9819,7 +9819,7 @@
                 <a:ea typeface="Arial" pitchFamily="34" charset="-122"/>
                 <a:cs typeface="Arial" pitchFamily="34" charset="-120"/>
               </a:rPr>
-              <a:t>It is the vehicle under the design—not the design itself.</a:t>
+              <a:t>That is what lets a page respond to clicks, selections, loading, errors, and new information.</a:t>
             </a:r>
             <a:endParaRPr lang="en-US" sz="1400" dirty="0"/>
           </a:p>
@@ -9978,7 +9978,7 @@
                 <a:ea typeface="Arial" pitchFamily="34" charset="-122"/>
                 <a:cs typeface="Arial" pitchFamily="34" charset="-120"/>
               </a:rPr>
-              <a:t>React, Angular, and Vue are different vehicles.</a:t>
+              <a:t>Why we’ll use React in this workshop</a:t>
             </a:r>
             <a:endParaRPr lang="en-US" sz="3100" dirty="0"/>
           </a:p>
@@ -10089,7 +10089,7 @@
                 <a:ea typeface="Arial" pitchFamily="34" charset="-122"/>
                 <a:cs typeface="Arial" pitchFamily="34" charset="-120"/>
               </a:rPr>
-              <a:t>Common Agent output; strong Modus wrappers</a:t>
+              <a:t>Common Agent output with strong Modus support</a:t>
             </a:r>
             <a:endParaRPr lang="en-US" sz="1250" dirty="0"/>
           </a:p>
@@ -10200,7 +10200,7 @@
                 <a:ea typeface="Arial" pitchFamily="34" charset="-122"/>
                 <a:cs typeface="Arial" pitchFamily="34" charset="-120"/>
               </a:rPr>
-              <a:t>Structured application framework; used in Trimble</a:t>
+              <a:t>Used by many structured enterprise applications</a:t>
             </a:r>
             <a:endParaRPr lang="en-US" sz="1250" dirty="0"/>
           </a:p>
@@ -10311,7 +10311,7 @@
                 <a:ea typeface="Arial" pitchFamily="34" charset="-122"/>
                 <a:cs typeface="Arial" pitchFamily="34" charset="-120"/>
               </a:rPr>
-              <a:t>Progressive framework; Modus wrapper exists</a:t>
+              <a:t>Another popular way to build interactive interfaces</a:t>
             </a:r>
             <a:endParaRPr lang="en-US" sz="1250" dirty="0"/>
           </a:p>
@@ -10352,7 +10352,7 @@
                 <a:ea typeface="Arial" pitchFamily="34" charset="-122"/>
                 <a:cs typeface="Arial" pitchFamily="34" charset="-120"/>
               </a:rPr>
-              <a:t>We choose React so one room follows one workflow—not because it is the only correct choice.</a:t>
+              <a:t>React is not the only option. We are choosing one setup so everyone can follow the same steps.</a:t>
             </a:r>
             <a:endParaRPr lang="en-US" sz="1400" dirty="0"/>
           </a:p>
@@ -10511,7 +10511,7 @@
                 <a:ea typeface="Arial" pitchFamily="34" charset="-122"/>
                 <a:cs typeface="Arial" pitchFamily="34" charset="-120"/>
               </a:rPr>
-              <a:t>You already have the two prerequisites.</a:t>
+              <a:t>Let’s start with a simple question.</a:t>
             </a:r>
             <a:endParaRPr lang="en-US" sz="3100" dirty="0"/>
           </a:p>
@@ -10552,7 +10552,7 @@
                 <a:ea typeface="Arial" pitchFamily="34" charset="-122"/>
                 <a:cs typeface="Arial" pitchFamily="34" charset="-120"/>
               </a:rPr>
-              <a:t>English. Design judgment.</a:t>
+              <a:t>Can Agent turn a clear description into a page we can use?</a:t>
             </a:r>
             <a:endParaRPr lang="en-US" sz="3800" dirty="0"/>
           </a:p>
@@ -10593,7 +10593,7 @@
                 <a:ea typeface="Arial" pitchFamily="34" charset="-122"/>
                 <a:cs typeface="Arial" pitchFamily="34" charset="-120"/>
               </a:rPr>
-              <a:t>Agent handles implementation. You own intent, interaction, quality, and the decision to accept or revise.</a:t>
+              <a:t>We’ll make one, look at what it understood, and tell it what to change.</a:t>
             </a:r>
             <a:endParaRPr lang="en-US" sz="1400" dirty="0"/>
           </a:p>
@@ -10752,7 +10752,7 @@
                 <a:ea typeface="Arial" pitchFamily="34" charset="-122"/>
                 <a:cs typeface="Arial" pitchFamily="34" charset="-120"/>
               </a:rPr>
-              <a:t>State is the screen’s memory right now.</a:t>
+              <a:t>What does the interface need to remember?</a:t>
             </a:r>
             <a:endParaRPr lang="en-US" sz="3100" dirty="0"/>
           </a:p>
@@ -10822,8 +10822,8 @@
         </p:nvSpPr>
         <p:spPr>
           <a:xfrm>
-            <a:off x="1508760" y="2514600"/>
-            <a:ext cx="2286000" cy="365760"/>
+            <a:off x="1417320" y="2514600"/>
+            <a:ext cx="2468880" cy="365760"/>
           </a:xfrm>
           <a:prstGeom prst="rect">
             <a:avLst/>
@@ -10841,7 +10841,7 @@
               <a:buNone/>
             </a:pPr>
             <a:r>
-              <a:rPr lang="en-US" sz="1900" b="1" dirty="0">
+              <a:rPr lang="en-US" sz="1700" b="1" dirty="0">
                 <a:solidFill>
                   <a:srgbClr val="1B242B"/>
                 </a:solidFill>
@@ -10849,9 +10849,9 @@
                 <a:ea typeface="Arial" pitchFamily="34" charset="-122"/>
                 <a:cs typeface="Arial" pitchFamily="34" charset="-120"/>
               </a:rPr>
-              <a:t>One living screen</a:t>
-            </a:r>
-            <a:endParaRPr lang="en-US" sz="1900" dirty="0"/>
+              <a:t>What the page remembers</a:t>
+            </a:r>
+            <a:endParaRPr lang="en-US" sz="1700" dirty="0"/>
           </a:p>
         </p:txBody>
       </p:sp>
@@ -10960,7 +10960,7 @@
                 <a:ea typeface="Arial" pitchFamily="34" charset="-122"/>
                 <a:cs typeface="Arial" pitchFamily="34" charset="-120"/>
               </a:rPr>
-              <a:t>Person clicks</a:t>
+              <a:t>User clicks</a:t>
             </a:r>
             <a:endParaRPr lang="en-US" sz="1400" dirty="0"/>
           </a:p>
@@ -11209,7 +11209,7 @@
                 <a:ea typeface="Arial" pitchFamily="34" charset="-122"/>
                 <a:cs typeface="Arial" pitchFamily="34" charset="-120"/>
               </a:rPr>
-              <a:t>Example: a panel is closed. Nothing needs to be duplicated.</a:t>
+              <a:t>Right now, the panel is closed. The interface needs to know that before the next action.</a:t>
             </a:r>
             <a:endParaRPr lang="en-US" sz="1400" dirty="0"/>
           </a:p>
@@ -11368,7 +11368,7 @@
                 <a:ea typeface="Arial" pitchFamily="34" charset="-122"/>
                 <a:cs typeface="Arial" pitchFamily="34" charset="-120"/>
               </a:rPr>
-              <a:t>An event changes that memory.</a:t>
+              <a:t>The user does something. The interface changes.</a:t>
             </a:r>
             <a:endParaRPr lang="en-US" sz="3100" dirty="0"/>
           </a:p>
@@ -11438,8 +11438,8 @@
         </p:nvSpPr>
         <p:spPr>
           <a:xfrm>
-            <a:off x="1508760" y="2514600"/>
-            <a:ext cx="2286000" cy="365760"/>
+            <a:off x="1417320" y="2514600"/>
+            <a:ext cx="2468880" cy="365760"/>
           </a:xfrm>
           <a:prstGeom prst="rect">
             <a:avLst/>
@@ -11457,7 +11457,7 @@
               <a:buNone/>
             </a:pPr>
             <a:r>
-              <a:rPr lang="en-US" sz="1900" b="1" dirty="0">
+              <a:rPr lang="en-US" sz="1700" b="1" dirty="0">
                 <a:solidFill>
                   <a:srgbClr val="1B242B"/>
                 </a:solidFill>
@@ -11465,9 +11465,9 @@
                 <a:ea typeface="Arial" pitchFamily="34" charset="-122"/>
                 <a:cs typeface="Arial" pitchFamily="34" charset="-120"/>
               </a:rPr>
-              <a:t>One living screen</a:t>
-            </a:r>
-            <a:endParaRPr lang="en-US" sz="1900" dirty="0"/>
+              <a:t>What the page remembers</a:t>
+            </a:r>
+            <a:endParaRPr lang="en-US" sz="1700" dirty="0"/>
           </a:p>
         </p:txBody>
       </p:sp>
@@ -11825,7 +11825,7 @@
                 <a:ea typeface="Arial" pitchFamily="34" charset="-122"/>
                 <a:cs typeface="Arial" pitchFamily="34" charset="-120"/>
               </a:rPr>
-              <a:t>The person clicks. “Open” changes from false to true. The same screen responds.</a:t>
+              <a:t>The person clicks, the panel opens, and the interface keeps track of the new state.</a:t>
             </a:r>
             <a:endParaRPr lang="en-US" sz="1400" dirty="0"/>
           </a:p>
@@ -11984,7 +11984,7 @@
                 <a:ea typeface="Arial" pitchFamily="34" charset="-122"/>
                 <a:cs typeface="Arial" pitchFamily="34" charset="-120"/>
               </a:rPr>
-              <a:t>Prompt the full experience—not only the happy screenshot.</a:t>
+              <a:t>A real flow includes the moments around success.</a:t>
             </a:r>
             <a:endParaRPr lang="en-US" sz="3100" dirty="0"/>
           </a:p>
@@ -12604,7 +12604,7 @@
                 <a:ea typeface="Arial" pitchFamily="34" charset="-122"/>
                 <a:cs typeface="Arial" pitchFamily="34" charset="-120"/>
               </a:rPr>
-              <a:t>Interaction lab: add one piece of memory.</a:t>
+              <a:t>Your turn: add one interaction.</a:t>
             </a:r>
             <a:endParaRPr lang="en-US" sz="3100" dirty="0"/>
           </a:p>
@@ -12672,7 +12672,7 @@
                 <a:ea typeface="Arial" pitchFamily="34" charset="-122"/>
                 <a:cs typeface="Arial" pitchFamily="34" charset="-120"/>
               </a:rPr>
-              <a:t>PROMPT IN AGENT</a:t>
+              <a:t>TRY THIS IN AGENT</a:t>
             </a:r>
             <a:endParaRPr lang="en-US" sz="1100" dirty="0"/>
           </a:p>
@@ -12713,7 +12713,7 @@
                 <a:ea typeface="Arial" pitchFamily="34" charset="-122"/>
                 <a:cs typeface="Arial" pitchFamily="34" charset="-120"/>
               </a:rPr>
-              <a:t>Add one behavior to this interface. When the user [acts], the interface should [respond]. Include what happens before, during, if it fails, and after success. Run and verify it in Preview.</a:t>
+              <a:t>Add one interaction to this page. When the user [does something], the page should [respond]. Show what happens before the action, while it is happening, if it fails, and after it works. Run it and let me try it in Preview.</a:t>
             </a:r>
             <a:endParaRPr lang="en-US" sz="2100" dirty="0"/>
           </a:p>
@@ -12754,7 +12754,7 @@
                 <a:ea typeface="Arial" pitchFamily="34" charset="-122"/>
                 <a:cs typeface="Arial" pitchFamily="34" charset="-120"/>
               </a:rPr>
-              <a:t>They choose the behavior: toggle, reveal, select, filter, validate, or confirm.</a:t>
+              <a:t>Choose something useful for your page: reveal, select, filter, validate, confirm, or another clear action.</a:t>
             </a:r>
             <a:endParaRPr lang="en-US" sz="1400" dirty="0"/>
           </a:p>
@@ -12913,7 +12913,7 @@
                 <a:ea typeface="Arial" pitchFamily="34" charset="-122"/>
                 <a:cs typeface="Arial" pitchFamily="34" charset="-120"/>
               </a:rPr>
-              <a:t>Phase 2 assessment</a:t>
+              <a:t>Quick check: does the interaction make sense?</a:t>
             </a:r>
             <a:endParaRPr lang="en-US" sz="3100" dirty="0"/>
           </a:p>
@@ -13024,7 +13024,7 @@
                 <a:ea typeface="Arial" pitchFamily="34" charset="-122"/>
                 <a:cs typeface="Arial" pitchFamily="34" charset="-120"/>
               </a:rPr>
-              <a:t>The same UI has a working interaction</a:t>
+              <a:t>The interaction works in Preview</a:t>
             </a:r>
             <a:endParaRPr lang="en-US" sz="1450" dirty="0"/>
           </a:p>
@@ -13135,7 +13135,7 @@
                 <a:ea typeface="Arial" pitchFamily="34" charset="-122"/>
                 <a:cs typeface="Arial" pitchFamily="34" charset="-120"/>
               </a:rPr>
-              <a:t>The participant can describe its memory in English</a:t>
+              <a:t>You can explain what the page needs to keep track of</a:t>
             </a:r>
             <a:endParaRPr lang="en-US" sz="1450" dirty="0"/>
           </a:p>
@@ -13357,7 +13357,7 @@
                 <a:ea typeface="Arial" pitchFamily="34" charset="-122"/>
                 <a:cs typeface="Arial" pitchFamily="34" charset="-120"/>
               </a:rPr>
-              <a:t>A peer can trigger and recover the flow</a:t>
+              <a:t>Someone else can use the flow and recover from it</a:t>
             </a:r>
             <a:endParaRPr lang="en-US" sz="1450" dirty="0"/>
           </a:p>
@@ -13398,7 +13398,7 @@
                 <a:ea typeface="Arial" pitchFamily="34" charset="-122"/>
                 <a:cs typeface="Arial" pitchFamily="34" charset="-120"/>
               </a:rPr>
-              <a:t>Gate: Ready · Ready with support · Not yet</a:t>
+              <a:t>Ready · Ready with a little help · Let’s fix this together</a:t>
             </a:r>
             <a:endParaRPr lang="en-US" sz="1400" dirty="0"/>
           </a:p>
@@ -13557,7 +13557,7 @@
                 <a:ea typeface="Arial" pitchFamily="34" charset="-122"/>
                 <a:cs typeface="Arial" pitchFamily="34" charset="-120"/>
               </a:rPr>
-              <a:t>Q&amp;A clinic</a:t>
+              <a:t>Questions before we give Agent more context?</a:t>
             </a:r>
             <a:endParaRPr lang="en-US" sz="3100" dirty="0"/>
           </a:p>
@@ -13948,7 +13948,7 @@
                 <a:ea typeface="Arial" pitchFamily="34" charset="-122"/>
                 <a:cs typeface="Arial" pitchFamily="34" charset="-120"/>
               </a:rPr>
-              <a:t>Then move from “understanding AI” to “giving AI a brain.”</a:t>
+              <a:t>Next we’ll connect Agent to the standards, files, and tools it needs for Modus work.</a:t>
             </a:r>
             <a:endParaRPr lang="en-US" sz="1400" dirty="0"/>
           </a:p>
@@ -14204,7 +14204,7 @@
                 <a:ea typeface="Arial" pitchFamily="34" charset="-122"/>
                 <a:cs typeface="Arial" pitchFamily="34" charset="-120"/>
               </a:rPr>
-              <a:t>Give Agent a Modus brain</a:t>
+              <a:t>Give Agent the right context and tools</a:t>
             </a:r>
             <a:endParaRPr lang="en-US" sz="2400" dirty="0"/>
           </a:p>
@@ -14245,7 +14245,7 @@
                 <a:ea typeface="Arial" pitchFamily="34" charset="-122"/>
                 <a:cs typeface="Arial" pitchFamily="34" charset="-120"/>
               </a:rPr>
-              <a:t>Day 1 · Afternoon · First big assessment</a:t>
+              <a:t>Day 1 · Afternoon · First full assessment</a:t>
             </a:r>
             <a:endParaRPr lang="en-US" sz="1300" dirty="0"/>
           </a:p>
@@ -14404,7 +14404,7 @@
                 <a:ea typeface="Arial" pitchFamily="34" charset="-122"/>
                 <a:cs typeface="Arial" pitchFamily="34" charset="-120"/>
               </a:rPr>
-              <a:t>A blank Agent is capable—but it has amnesia.</a:t>
+              <a:t>A general Agent does not know our product decisions yet.</a:t>
             </a:r>
             <a:endParaRPr lang="en-US" sz="3100" dirty="0"/>
           </a:p>
@@ -14515,7 +14515,7 @@
                 <a:ea typeface="Arial" pitchFamily="34" charset="-122"/>
                 <a:cs typeface="Arial" pitchFamily="34" charset="-120"/>
               </a:rPr>
-              <a:t>Permanent guardrails</a:t>
+              <a:t>Standards that apply to every request</a:t>
             </a:r>
             <a:endParaRPr lang="en-US" sz="1250" dirty="0"/>
           </a:p>
@@ -14626,7 +14626,7 @@
                 <a:ea typeface="Arial" pitchFamily="34" charset="-122"/>
                 <a:cs typeface="Arial" pitchFamily="34" charset="-120"/>
               </a:rPr>
-              <a:t>Focused recipes</a:t>
+              <a:t>Step-by-step guidance for common tasks</a:t>
             </a:r>
             <a:endParaRPr lang="en-US" sz="1250" dirty="0"/>
           </a:p>
@@ -14737,7 +14737,7 @@
                 <a:ea typeface="Arial" pitchFamily="34" charset="-122"/>
                 <a:cs typeface="Arial" pitchFamily="34" charset="-120"/>
               </a:rPr>
-              <a:t>Connected tools and facts</a:t>
+              <a:t>Connections to tools and current information</a:t>
             </a:r>
             <a:endParaRPr lang="en-US" sz="1250" dirty="0"/>
           </a:p>
@@ -15118,7 +15118,7 @@
                 <a:ea typeface="Arial" pitchFamily="34" charset="-122"/>
                 <a:cs typeface="Arial" pitchFamily="34" charset="-120"/>
               </a:rPr>
-              <a:t>Use the official Modus one-step setup.</a:t>
+              <a:t>Start with the Modus setup page.</a:t>
             </a:r>
             <a:endParaRPr lang="en-US" sz="3100" dirty="0"/>
           </a:p>
@@ -15159,7 +15159,7 @@
                 <a:ea typeface="Arial" pitchFamily="34" charset="-122"/>
                 <a:cs typeface="Arial" pitchFamily="34" charset="-120"/>
               </a:rPr>
-              <a:t>One prompt installs the Docs MCP, user rules, and user skills.</a:t>
+              <a:t>One setup prompt adds the Modus docs, rules, and skills to Cursor.</a:t>
             </a:r>
             <a:endParaRPr lang="en-US" sz="3800" dirty="0"/>
           </a:p>
@@ -15359,7 +15359,7 @@
                 <a:ea typeface="Arial" pitchFamily="34" charset="-122"/>
                 <a:cs typeface="Arial" pitchFamily="34" charset="-120"/>
               </a:rPr>
-              <a:t>Rules are permanent guardrails.</a:t>
+              <a:t>Rules keep the same standards across requests.</a:t>
             </a:r>
             <a:endParaRPr lang="en-US" sz="3100" dirty="0"/>
           </a:p>
@@ -15868,7 +15868,7 @@
                 <a:ea typeface="Arial" pitchFamily="34" charset="-122"/>
                 <a:cs typeface="Arial" pitchFamily="34" charset="-120"/>
               </a:rPr>
-              <a:t>Your circle—and the engineering boundary</a:t>
+              <a:t>What we’ll do here—and what happens before production</a:t>
             </a:r>
             <a:endParaRPr lang="en-US" sz="3100" dirty="0"/>
           </a:p>
@@ -15967,7 +15967,7 @@
                 <a:ea typeface="Arial" pitchFamily="34" charset="-122"/>
                 <a:cs typeface="Arial" pitchFamily="34" charset="-120"/>
               </a:rPr>
-              <a:t>Designers own</a:t>
+              <a:t>In this workshop</a:t>
             </a:r>
             <a:endParaRPr lang="en-US" sz="2000" dirty="0"/>
           </a:p>
@@ -16008,7 +16008,7 @@
                 <a:ea typeface="Arial" pitchFamily="34" charset="-122"/>
                 <a:cs typeface="Arial" pitchFamily="34" charset="-120"/>
               </a:rPr>
-              <a:t>Engineering owns</a:t>
+              <a:t>Before real production</a:t>
             </a:r>
             <a:endParaRPr lang="en-US" sz="2000" dirty="0"/>
           </a:p>
@@ -17151,7 +17151,7 @@
                 <a:ea typeface="Arial" pitchFamily="34" charset="-122"/>
                 <a:cs typeface="Arial" pitchFamily="34" charset="-120"/>
               </a:rPr>
-              <a:t>Skills are recipes for recurring work.</a:t>
+              <a:t>Skills show Agent how to handle common tasks.</a:t>
             </a:r>
             <a:endParaRPr lang="en-US" sz="3100" dirty="0"/>
           </a:p>
@@ -17660,7 +17660,7 @@
                 <a:ea typeface="Arial" pitchFamily="34" charset="-122"/>
                 <a:cs typeface="Arial" pitchFamily="34" charset="-120"/>
               </a:rPr>
-              <a:t>MCP connects Agent to live tools and facts.</a:t>
+              <a:t>MCP lets Agent use information from other tools.</a:t>
             </a:r>
             <a:endParaRPr lang="en-US" sz="3100" dirty="0"/>
           </a:p>
@@ -18099,7 +18099,7 @@
                 <a:ea typeface="Arial" pitchFamily="34" charset="-122"/>
                 <a:cs typeface="Arial" pitchFamily="34" charset="-120"/>
               </a:rPr>
-              <a:t>Figma → Agent → Modus-aware implementation</a:t>
+              <a:t>Bring a Figma selection into the same conversation.</a:t>
             </a:r>
             <a:endParaRPr lang="en-US" sz="3100" dirty="0"/>
           </a:p>
@@ -18210,7 +18210,7 @@
                 <a:ea typeface="Arial" pitchFamily="34" charset="-122"/>
                 <a:cs typeface="Arial" pitchFamily="34" charset="-120"/>
               </a:rPr>
-              <a:t>Use Modus 2.0 library</a:t>
+              <a:t>Use the Modus 2.0 library</a:t>
             </a:r>
             <a:endParaRPr lang="en-US" sz="1390" dirty="0"/>
           </a:p>
@@ -18321,7 +18321,7 @@
                 <a:ea typeface="Arial" pitchFamily="34" charset="-122"/>
                 <a:cs typeface="Arial" pitchFamily="34" charset="-120"/>
               </a:rPr>
-              <a:t>Copy link to selection</a:t>
+              <a:t>Copy a link to the selection</a:t>
             </a:r>
             <a:endParaRPr lang="en-US" sz="1390" dirty="0"/>
           </a:p>
@@ -18432,7 +18432,7 @@
                 <a:ea typeface="Arial" pitchFamily="34" charset="-122"/>
                 <a:cs typeface="Arial" pitchFamily="34" charset="-120"/>
               </a:rPr>
-              <a:t>Paste into Agent</a:t>
+              <a:t>Paste it into Agent</a:t>
             </a:r>
             <a:endParaRPr lang="en-US" sz="1390" dirty="0"/>
           </a:p>
@@ -18543,7 +18543,7 @@
                 <a:ea typeface="Arial" pitchFamily="34" charset="-122"/>
                 <a:cs typeface="Arial" pitchFamily="34" charset="-120"/>
               </a:rPr>
-              <a:t>Name user goal + states</a:t>
+              <a:t>Explain the goal and states</a:t>
             </a:r>
             <a:endParaRPr lang="en-US" sz="1390" dirty="0"/>
           </a:p>
@@ -18654,7 +18654,7 @@
                 <a:ea typeface="Arial" pitchFamily="34" charset="-122"/>
                 <a:cs typeface="Arial" pitchFamily="34" charset="-120"/>
               </a:rPr>
-              <a:t>Run in Browser</a:t>
+              <a:t>Run it in Preview</a:t>
             </a:r>
             <a:endParaRPr lang="en-US" sz="1390" dirty="0"/>
           </a:p>
@@ -18765,7 +18765,7 @@
                 <a:ea typeface="Arial" pitchFamily="34" charset="-122"/>
                 <a:cs typeface="Arial" pitchFamily="34" charset="-120"/>
               </a:rPr>
-              <a:t>Compare and revise</a:t>
+              <a:t>Compare and adjust</a:t>
             </a:r>
             <a:endParaRPr lang="en-US" sz="1390" dirty="0"/>
           </a:p>
@@ -18965,7 +18965,7 @@
                 <a:ea typeface="Arial" pitchFamily="34" charset="-122"/>
                 <a:cs typeface="Arial" pitchFamily="34" charset="-120"/>
               </a:rPr>
-              <a:t>Useful additions—only when they match the work</a:t>
+              <a:t>Add other connections only when your team needs them.</a:t>
             </a:r>
             <a:endParaRPr lang="en-US" sz="3100" dirty="0"/>
           </a:p>
@@ -19679,7 +19679,7 @@
                 <a:ea typeface="Arial" pitchFamily="34" charset="-122"/>
                 <a:cs typeface="Arial" pitchFamily="34" charset="-120"/>
               </a:rPr>
-              <a:t>Phase 3 big assessment</a:t>
+              <a:t>First full assessment: use the connected workflow</a:t>
             </a:r>
             <a:endParaRPr lang="en-US" sz="3100" dirty="0"/>
           </a:p>
@@ -19790,7 +19790,7 @@
                 <a:ea typeface="Arial" pitchFamily="34" charset="-122"/>
                 <a:cs typeface="Arial" pitchFamily="34" charset="-120"/>
               </a:rPr>
-              <a:t>Official Modus setup completed</a:t>
+              <a:t>The Modus setup is complete</a:t>
             </a:r>
             <a:endParaRPr lang="en-US" sz="1450" dirty="0"/>
           </a:p>
@@ -19901,7 +19901,7 @@
                 <a:ea typeface="Arial" pitchFamily="34" charset="-122"/>
                 <a:cs typeface="Arial" pitchFamily="34" charset="-120"/>
               </a:rPr>
-              <a:t>Figma plugin/MCP is connected</a:t>
+              <a:t>Figma is connected</a:t>
             </a:r>
             <a:endParaRPr lang="en-US" sz="1450" dirty="0"/>
           </a:p>
@@ -20012,7 +20012,7 @@
                 <a:ea typeface="Arial" pitchFamily="34" charset="-122"/>
                 <a:cs typeface="Arial" pitchFamily="34" charset="-120"/>
               </a:rPr>
-              <a:t>A Figma selection—not only a screenshot—was used</a:t>
+              <a:t>You used a link to a Figma selection</a:t>
             </a:r>
             <a:endParaRPr lang="en-US" sz="1450" dirty="0"/>
           </a:p>
@@ -20123,7 +20123,7 @@
                 <a:ea typeface="Arial" pitchFamily="34" charset="-122"/>
                 <a:cs typeface="Arial" pitchFamily="34" charset="-120"/>
               </a:rPr>
-              <a:t>Agent verifies the app in Browser</a:t>
+              <a:t>Agent checked the page in Preview</a:t>
             </a:r>
             <a:endParaRPr lang="en-US" sz="1450" dirty="0"/>
           </a:p>
@@ -20234,7 +20234,7 @@
                 <a:ea typeface="Arial" pitchFamily="34" charset="-122"/>
                 <a:cs typeface="Arial" pitchFamily="34" charset="-120"/>
               </a:rPr>
-              <a:t>Participant restores one Checkpoint</a:t>
+              <a:t>You can restore a Checkpoint</a:t>
             </a:r>
             <a:endParaRPr lang="en-US" sz="1450" dirty="0"/>
           </a:p>
@@ -20345,7 +20345,7 @@
                 <a:ea typeface="Arial" pitchFamily="34" charset="-122"/>
                 <a:cs typeface="Arial" pitchFamily="34" charset="-120"/>
               </a:rPr>
-              <a:t>Interaction still works</a:t>
+              <a:t>The interaction still works</a:t>
             </a:r>
             <a:endParaRPr lang="en-US" sz="1450" dirty="0"/>
           </a:p>
@@ -20386,7 +20386,7 @@
                 <a:ea typeface="Arial" pitchFamily="34" charset="-122"/>
                 <a:cs typeface="Arial" pitchFamily="34" charset="-120"/>
               </a:rPr>
-              <a:t>After this gate: ready to do AI independently</a:t>
+              <a:t>Goal: complete the workflow with little or no facilitator help</a:t>
             </a:r>
             <a:endParaRPr lang="en-US" sz="1400" dirty="0"/>
           </a:p>
@@ -20545,7 +20545,7 @@
                 <a:ea typeface="Arial" pitchFamily="34" charset="-122"/>
                 <a:cs typeface="Arial" pitchFamily="34" charset="-120"/>
               </a:rPr>
-              <a:t>Day 1 reflection + Q&amp;A</a:t>
+              <a:t>What helped? What still needed your input?</a:t>
             </a:r>
             <a:endParaRPr lang="en-US" sz="3100" dirty="0"/>
           </a:p>
@@ -20615,7 +20615,7 @@
                 <a:ea typeface="Arial" pitchFamily="34" charset="-122"/>
                 <a:cs typeface="Arial" pitchFamily="34" charset="-120"/>
               </a:rPr>
-              <a:t>What did the brain change?</a:t>
+              <a:t>What changed after adding Modus context?</a:t>
             </a:r>
             <a:endParaRPr lang="en-US" sz="1800" dirty="0"/>
           </a:p>
@@ -20685,7 +20685,7 @@
                 <a:ea typeface="Arial" pitchFamily="34" charset="-122"/>
                 <a:cs typeface="Arial" pitchFamily="34" charset="-120"/>
               </a:rPr>
-              <a:t>Where did Agent guess?</a:t>
+              <a:t>Where did Agent still guess?</a:t>
             </a:r>
             <a:endParaRPr lang="en-US" sz="1800" dirty="0"/>
           </a:p>
@@ -20755,7 +20755,7 @@
                 <a:ea typeface="Arial" pitchFamily="34" charset="-122"/>
                 <a:cs typeface="Arial" pitchFamily="34" charset="-120"/>
               </a:rPr>
-              <a:t>What did Browser prove?</a:t>
+              <a:t>What did Preview help you catch?</a:t>
             </a:r>
             <a:endParaRPr lang="en-US" sz="1800" dirty="0"/>
           </a:p>
@@ -20825,7 +20825,7 @@
                 <a:ea typeface="Arial" pitchFamily="34" charset="-122"/>
                 <a:cs typeface="Arial" pitchFamily="34" charset="-120"/>
               </a:rPr>
-              <a:t>What remains a designer decision?</a:t>
+              <a:t>Which decisions were still yours?</a:t>
             </a:r>
             <a:endParaRPr lang="en-US" sz="1800" dirty="0"/>
           </a:p>
@@ -20866,7 +20866,7 @@
                 <a:ea typeface="Arial" pitchFamily="34" charset="-122"/>
                 <a:cs typeface="Arial" pitchFamily="34" charset="-120"/>
               </a:rPr>
-              <a:t>Tomorrow: use the company vehicle and raise the quality bar.</a:t>
+              <a:t>Tomorrow we’ll use the same workflow to build and check the Modus version.</a:t>
             </a:r>
             <a:endParaRPr lang="en-US" sz="1400" dirty="0"/>
           </a:p>
@@ -21122,7 +21122,7 @@
                 <a:ea typeface="Arial" pitchFamily="34" charset="-122"/>
                 <a:cs typeface="Arial" pitchFamily="34" charset="-120"/>
               </a:rPr>
-              <a:t>Build the production-quality Modus version</a:t>
+              <a:t>Build and check the Modus version</a:t>
             </a:r>
             <a:endParaRPr lang="en-US" sz="2400" dirty="0"/>
           </a:p>
@@ -21322,7 +21322,7 @@
                 <a:ea typeface="Arial" pitchFamily="34" charset="-122"/>
                 <a:cs typeface="Arial" pitchFamily="34" charset="-120"/>
               </a:rPr>
-              <a:t>Modus already built the road.</a:t>
+              <a:t>Use the Modus site as your reference.</a:t>
             </a:r>
             <a:endParaRPr lang="en-US" sz="3100" dirty="0"/>
           </a:p>
@@ -22147,7 +22147,7 @@
                 <a:ea typeface="Arial" pitchFamily="34" charset="-122"/>
                 <a:cs typeface="Arial" pitchFamily="34" charset="-120"/>
               </a:rPr>
-              <a:t>Use progressively larger building blocks.</a:t>
+              <a:t>Start with what already exists.</a:t>
             </a:r>
             <a:endParaRPr lang="en-US" sz="3100" dirty="0"/>
           </a:p>
@@ -22538,7 +22538,7 @@
                 <a:ea typeface="Arial" pitchFamily="34" charset="-122"/>
                 <a:cs typeface="Arial" pitchFamily="34" charset="-120"/>
               </a:rPr>
-              <a:t>Adapt existing language. Do not ask Agent to invent a parallel design system.</a:t>
+              <a:t>Use Modus foundations, components, patterns, and templates before asking Agent to invent something new.</a:t>
             </a:r>
             <a:endParaRPr lang="en-US" sz="1400" dirty="0"/>
           </a:p>
@@ -22697,7 +22697,7 @@
                 <a:ea typeface="Arial" pitchFamily="34" charset="-122"/>
                 <a:cs typeface="Arial" pitchFamily="34" charset="-120"/>
               </a:rPr>
-              <a:t>Production quality is more than visual fidelity.</a:t>
+              <a:t>A good prototype needs more than the right look.</a:t>
             </a:r>
             <a:endParaRPr lang="en-US" sz="3100" dirty="0"/>
           </a:p>
@@ -22767,7 +22767,7 @@
                 <a:ea typeface="Arial" pitchFamily="34" charset="-122"/>
                 <a:cs typeface="Arial" pitchFamily="34" charset="-120"/>
               </a:rPr>
-              <a:t>Intentional task flow</a:t>
+              <a:t>A clear task flow</a:t>
             </a:r>
             <a:endParaRPr lang="en-US" sz="1800" dirty="0"/>
           </a:p>
@@ -22837,7 +22837,7 @@
                 <a:ea typeface="Arial" pitchFamily="34" charset="-122"/>
                 <a:cs typeface="Arial" pitchFamily="34" charset="-120"/>
               </a:rPr>
-              <a:t>Complete states</a:t>
+              <a:t>The states people will actually encounter</a:t>
             </a:r>
             <a:endParaRPr lang="en-US" sz="1800" dirty="0"/>
           </a:p>
@@ -22977,7 +22977,7 @@
                 <a:ea typeface="Arial" pitchFamily="34" charset="-122"/>
                 <a:cs typeface="Arial" pitchFamily="34" charset="-120"/>
               </a:rPr>
-              <a:t>Responsive layout</a:t>
+              <a:t>A layout that works at different widths</a:t>
             </a:r>
             <a:endParaRPr lang="en-US" sz="1800" dirty="0"/>
           </a:p>
@@ -23047,7 +23047,7 @@
                 <a:ea typeface="Arial" pitchFamily="34" charset="-122"/>
                 <a:cs typeface="Arial" pitchFamily="34" charset="-120"/>
               </a:rPr>
-              <a:t>Keyboard and visible focus</a:t>
+              <a:t>Keyboard use and visible focus</a:t>
             </a:r>
             <a:endParaRPr lang="en-US" sz="1800" dirty="0"/>
           </a:p>
@@ -23117,7 +23117,7 @@
                 <a:ea typeface="Arial" pitchFamily="34" charset="-122"/>
                 <a:cs typeface="Arial" pitchFamily="34" charset="-120"/>
               </a:rPr>
-              <a:t>Truthful data assumptions</a:t>
+              <a:t>Honest data assumptions</a:t>
             </a:r>
             <a:endParaRPr lang="en-US" sz="1800" dirty="0"/>
           </a:p>
@@ -23187,7 +23187,7 @@
                 <a:ea typeface="Arial" pitchFamily="34" charset="-122"/>
                 <a:cs typeface="Arial" pitchFamily="34" charset="-120"/>
               </a:rPr>
-              <a:t>Shareable evidence</a:t>
+              <a:t>A result others can open and test</a:t>
             </a:r>
             <a:endParaRPr lang="en-US" sz="1800" dirty="0"/>
           </a:p>
@@ -23346,7 +23346,7 @@
                 <a:ea typeface="Arial" pitchFamily="34" charset="-122"/>
                 <a:cs typeface="Arial" pitchFamily="34" charset="-120"/>
               </a:rPr>
-              <a:t>The operating loop</a:t>
+              <a:t>This is the loop we’ll use all the way through.</a:t>
             </a:r>
             <a:endParaRPr lang="en-US" sz="3100" dirty="0"/>
           </a:p>
@@ -23457,7 +23457,7 @@
                 <a:ea typeface="Arial" pitchFamily="34" charset="-122"/>
                 <a:cs typeface="Arial" pitchFamily="34" charset="-120"/>
               </a:rPr>
-              <a:t>Frame</a:t>
+              <a:t>Describe</a:t>
             </a:r>
             <a:endParaRPr lang="en-US" sz="1285" dirty="0"/>
           </a:p>
@@ -23568,7 +23568,7 @@
                 <a:ea typeface="Arial" pitchFamily="34" charset="-122"/>
                 <a:cs typeface="Arial" pitchFamily="34" charset="-120"/>
               </a:rPr>
-              <a:t>Constrain</a:t>
+              <a:t>Set limits</a:t>
             </a:r>
             <a:endParaRPr lang="en-US" sz="1285" dirty="0"/>
           </a:p>
@@ -23679,7 +23679,7 @@
                 <a:ea typeface="Arial" pitchFamily="34" charset="-122"/>
                 <a:cs typeface="Arial" pitchFamily="34" charset="-120"/>
               </a:rPr>
-              <a:t>Generate</a:t>
+              <a:t>Build</a:t>
             </a:r>
             <a:endParaRPr lang="en-US" sz="1285" dirty="0"/>
           </a:p>
@@ -23790,7 +23790,7 @@
                 <a:ea typeface="Arial" pitchFamily="34" charset="-122"/>
                 <a:cs typeface="Arial" pitchFamily="34" charset="-120"/>
               </a:rPr>
-              <a:t>Inspect</a:t>
+              <a:t>Look</a:t>
             </a:r>
             <a:endParaRPr lang="en-US" sz="1285" dirty="0"/>
           </a:p>
@@ -23901,7 +23901,7 @@
                 <a:ea typeface="Arial" pitchFamily="34" charset="-122"/>
                 <a:cs typeface="Arial" pitchFamily="34" charset="-120"/>
               </a:rPr>
-              <a:t>Test</a:t>
+              <a:t>Try it</a:t>
             </a:r>
             <a:endParaRPr lang="en-US" sz="1285" dirty="0"/>
           </a:p>
@@ -24012,7 +24012,7 @@
                 <a:ea typeface="Arial" pitchFamily="34" charset="-122"/>
                 <a:cs typeface="Arial" pitchFamily="34" charset="-120"/>
               </a:rPr>
-              <a:t>Diagnose</a:t>
+              <a:t>Spot the issue</a:t>
             </a:r>
             <a:endParaRPr lang="en-US" sz="1285" dirty="0"/>
           </a:p>
@@ -24123,7 +24123,7 @@
                 <a:ea typeface="Arial" pitchFamily="34" charset="-122"/>
                 <a:cs typeface="Arial" pitchFamily="34" charset="-120"/>
               </a:rPr>
-              <a:t>Revise</a:t>
+              <a:t>Adjust</a:t>
             </a:r>
             <a:endParaRPr lang="en-US" sz="1285" dirty="0"/>
           </a:p>
@@ -24234,7 +24234,7 @@
                 <a:ea typeface="Arial" pitchFamily="34" charset="-122"/>
                 <a:cs typeface="Arial" pitchFamily="34" charset="-120"/>
               </a:rPr>
-              <a:t>Re-test</a:t>
+              <a:t>Check again</a:t>
             </a:r>
             <a:endParaRPr lang="en-US" sz="1285" dirty="0"/>
           </a:p>
@@ -24345,7 +24345,7 @@
                 <a:ea typeface="Arial" pitchFamily="34" charset="-122"/>
                 <a:cs typeface="Arial" pitchFamily="34" charset="-120"/>
               </a:rPr>
-              <a:t>Document</a:t>
+              <a:t>Share</a:t>
             </a:r>
             <a:endParaRPr lang="en-US" sz="1285" dirty="0"/>
           </a:p>
@@ -24386,7 +24386,7 @@
                 <a:ea typeface="Arial" pitchFamily="34" charset="-122"/>
                 <a:cs typeface="Arial" pitchFamily="34" charset="-120"/>
               </a:rPr>
-              <a:t>Prompt cleverness is not the skill. Specification, observation, and verification are.</a:t>
+              <a:t>The first prompt is only a starting point. Most of the work happens when we look at the result and respond clearly.</a:t>
             </a:r>
             <a:endParaRPr lang="en-US" sz="1400" dirty="0"/>
           </a:p>
@@ -24545,7 +24545,7 @@
                 <a:ea typeface="Arial" pitchFamily="34" charset="-122"/>
                 <a:cs typeface="Arial" pitchFamily="34" charset="-120"/>
               </a:rPr>
-              <a:t>Agent builds. Browser provides evidence.</a:t>
+              <a:t>Check the result in the browser.</a:t>
             </a:r>
             <a:endParaRPr lang="en-US" sz="3100" dirty="0"/>
           </a:p>
@@ -24656,7 +24656,7 @@
                 <a:ea typeface="Arial" pitchFamily="34" charset="-122"/>
                 <a:cs typeface="Arial" pitchFamily="34" charset="-120"/>
               </a:rPr>
-              <a:t>Complete the task</a:t>
+              <a:t>Complete the main task</a:t>
             </a:r>
             <a:endParaRPr lang="en-US" sz="1390" dirty="0"/>
           </a:p>
@@ -24767,7 +24767,7 @@
                 <a:ea typeface="Arial" pitchFamily="34" charset="-122"/>
                 <a:cs typeface="Arial" pitchFamily="34" charset="-120"/>
               </a:rPr>
-              <a:t>Test empty/loading/error/success</a:t>
+              <a:t>Try empty, loading, error, and success</a:t>
             </a:r>
             <a:endParaRPr lang="en-US" sz="1390" dirty="0"/>
           </a:p>
@@ -24878,7 +24878,7 @@
                 <a:ea typeface="Arial" pitchFamily="34" charset="-122"/>
                 <a:cs typeface="Arial" pitchFamily="34" charset="-120"/>
               </a:rPr>
-              <a:t>Use keyboard only</a:t>
+              <a:t>Use only the keyboard</a:t>
             </a:r>
             <a:endParaRPr lang="en-US" sz="1390" dirty="0"/>
           </a:p>
@@ -24989,7 +24989,7 @@
                 <a:ea typeface="Arial" pitchFamily="34" charset="-122"/>
                 <a:cs typeface="Arial" pitchFamily="34" charset="-120"/>
               </a:rPr>
-              <a:t>Check narrow + wide</a:t>
+              <a:t>Check narrow and wide views</a:t>
             </a:r>
             <a:endParaRPr lang="en-US" sz="1390" dirty="0"/>
           </a:p>
@@ -25100,7 +25100,7 @@
                 <a:ea typeface="Arial" pitchFamily="34" charset="-122"/>
                 <a:cs typeface="Arial" pitchFamily="34" charset="-120"/>
               </a:rPr>
-              <a:t>Stress long content</a:t>
+              <a:t>Try longer content</a:t>
             </a:r>
             <a:endParaRPr lang="en-US" sz="1390" dirty="0"/>
           </a:p>
@@ -25211,7 +25211,7 @@
                 <a:ea typeface="Arial" pitchFamily="34" charset="-122"/>
                 <a:cs typeface="Arial" pitchFamily="34" charset="-120"/>
               </a:rPr>
-              <a:t>Re-test earlier behavior</a:t>
+              <a:t>Re-test what worked before</a:t>
             </a:r>
             <a:endParaRPr lang="en-US" sz="1390" dirty="0"/>
           </a:p>
@@ -25370,7 +25370,7 @@
                 <a:ea typeface="Arial" pitchFamily="34" charset="-122"/>
                 <a:cs typeface="Arial" pitchFamily="34" charset="-120"/>
               </a:rPr>
-              <a:t>Repair drill: evidence before instruction.</a:t>
+              <a:t>When something is wrong, be specific.</a:t>
             </a:r>
             <a:endParaRPr lang="en-US" sz="3100" dirty="0"/>
           </a:p>
@@ -25481,7 +25481,7 @@
                 <a:ea typeface="Arial" pitchFamily="34" charset="-122"/>
                 <a:cs typeface="Arial" pitchFamily="34" charset="-120"/>
               </a:rPr>
-              <a:t>Observe symptom</a:t>
+              <a:t>Show what happened</a:t>
             </a:r>
             <a:endParaRPr lang="en-US" sz="1425" dirty="0"/>
           </a:p>
@@ -25592,7 +25592,7 @@
                 <a:ea typeface="Arial" pitchFamily="34" charset="-122"/>
                 <a:cs typeface="Arial" pitchFamily="34" charset="-120"/>
               </a:rPr>
-              <a:t>State a hypothesis</a:t>
+              <a:t>Explain why it is a problem</a:t>
             </a:r>
             <a:endParaRPr lang="en-US" sz="1425" dirty="0"/>
           </a:p>
@@ -25703,7 +25703,7 @@
                 <a:ea typeface="Arial" pitchFamily="34" charset="-122"/>
                 <a:cs typeface="Arial" pitchFamily="34" charset="-120"/>
               </a:rPr>
-              <a:t>Ask one bounded correction</a:t>
+              <a:t>Ask for one focused change</a:t>
             </a:r>
             <a:endParaRPr lang="en-US" sz="1425" dirty="0"/>
           </a:p>
@@ -25814,7 +25814,7 @@
                 <a:ea typeface="Arial" pitchFamily="34" charset="-122"/>
                 <a:cs typeface="Arial" pitchFamily="34" charset="-120"/>
               </a:rPr>
-              <a:t>Verify the fix</a:t>
+              <a:t>Try the fix</a:t>
             </a:r>
             <a:endParaRPr lang="en-US" sz="1425" dirty="0"/>
           </a:p>
@@ -25925,7 +25925,7 @@
                 <a:ea typeface="Arial" pitchFamily="34" charset="-122"/>
                 <a:cs typeface="Arial" pitchFamily="34" charset="-120"/>
               </a:rPr>
-              <a:t>Regression-check the flow</a:t>
+              <a:t>Check the rest of the flow again</a:t>
             </a:r>
             <a:endParaRPr lang="en-US" sz="1425" dirty="0"/>
           </a:p>
@@ -25966,7 +25966,7 @@
                 <a:ea typeface="Arial" pitchFamily="34" charset="-122"/>
                 <a:cs typeface="Arial" pitchFamily="34" charset="-120"/>
               </a:rPr>
-              <a:t>Do not say “make it better.” Say what failed, where, and what acceptance looks like.</a:t>
+              <a:t>Instead of “make it better,” say what failed, where it failed, and what should happen instead.</a:t>
             </a:r>
             <a:endParaRPr lang="en-US" sz="1400" dirty="0"/>
           </a:p>
@@ -26125,7 +26125,7 @@
                 <a:ea typeface="Arial" pitchFamily="34" charset="-122"/>
                 <a:cs typeface="Arial" pitchFamily="34" charset="-120"/>
               </a:rPr>
-              <a:t>Phase 4 assessment</a:t>
+              <a:t>Modus build check</a:t>
             </a:r>
             <a:endParaRPr lang="en-US" sz="3100" dirty="0"/>
           </a:p>
@@ -26236,7 +26236,7 @@
                 <a:ea typeface="Arial" pitchFamily="34" charset="-122"/>
                 <a:cs typeface="Arial" pitchFamily="34" charset="-120"/>
               </a:rPr>
-              <a:t>Looks and behaves like Modus</a:t>
+              <a:t>The interface uses Modus consistently</a:t>
             </a:r>
             <a:endParaRPr lang="en-US" sz="1450" dirty="0"/>
           </a:p>
@@ -26347,7 +26347,7 @@
                 <a:ea typeface="Arial" pitchFamily="34" charset="-122"/>
                 <a:cs typeface="Arial" pitchFamily="34" charset="-120"/>
               </a:rPr>
-              <a:t>Relevant states work</a:t>
+              <a:t>The important states work</a:t>
             </a:r>
             <a:endParaRPr lang="en-US" sz="1450" dirty="0"/>
           </a:p>
@@ -26458,7 +26458,7 @@
                 <a:ea typeface="Arial" pitchFamily="34" charset="-122"/>
                 <a:cs typeface="Arial" pitchFamily="34" charset="-120"/>
               </a:rPr>
-              <a:t>Peer completes task without explanation</a:t>
+              <a:t>Someone else can complete the task without help</a:t>
             </a:r>
             <a:endParaRPr lang="en-US" sz="1450" dirty="0"/>
           </a:p>
@@ -26569,7 +26569,7 @@
                 <a:ea typeface="Arial" pitchFamily="34" charset="-122"/>
                 <a:cs typeface="Arial" pitchFamily="34" charset="-120"/>
               </a:rPr>
-              <a:t>Narrow and wide layouts pass</a:t>
+              <a:t>Narrow and wide layouts work</a:t>
             </a:r>
             <a:endParaRPr lang="en-US" sz="1450" dirty="0"/>
           </a:p>
@@ -26680,7 +26680,7 @@
                 <a:ea typeface="Arial" pitchFamily="34" charset="-122"/>
                 <a:cs typeface="Arial" pitchFamily="34" charset="-120"/>
               </a:rPr>
-              <a:t>Keyboard/focus/labels are checked</a:t>
+              <a:t>Keyboard, focus, and labels were checked</a:t>
             </a:r>
             <a:endParaRPr lang="en-US" sz="1450" dirty="0"/>
           </a:p>
@@ -26791,7 +26791,7 @@
                 <a:ea typeface="Arial" pitchFamily="34" charset="-122"/>
                 <a:cs typeface="Arial" pitchFamily="34" charset="-120"/>
               </a:rPr>
-              <a:t>Known limits are stated</a:t>
+              <a:t>You can explain what is not finished</a:t>
             </a:r>
             <a:endParaRPr lang="en-US" sz="1450" dirty="0"/>
           </a:p>
@@ -26832,7 +26832,7 @@
                 <a:ea typeface="Arial" pitchFamily="34" charset="-122"/>
                 <a:cs typeface="Arial" pitchFamily="34" charset="-120"/>
               </a:rPr>
-              <a:t>Build gate: product quality, not code knowledge</a:t>
+              <a:t>We are checking the experience—not the generated code</a:t>
             </a:r>
             <a:endParaRPr lang="en-US" sz="1400" dirty="0"/>
           </a:p>
@@ -26991,7 +26991,7 @@
                 <a:ea typeface="Arial" pitchFamily="34" charset="-122"/>
                 <a:cs typeface="Arial" pitchFamily="34" charset="-120"/>
               </a:rPr>
-              <a:t>Q&amp;A clinic</a:t>
+              <a:t>Questions before we share it?</a:t>
             </a:r>
             <a:endParaRPr lang="en-US" sz="3100" dirty="0"/>
           </a:p>
@@ -27382,7 +27382,7 @@
                 <a:ea typeface="Arial" pitchFamily="34" charset="-122"/>
                 <a:cs typeface="Arial" pitchFamily="34" charset="-120"/>
               </a:rPr>
-              <a:t>Then make the work available to other people.</a:t>
+              <a:t>Next we’ll move the prototype from one Mac to links that other people can open.</a:t>
             </a:r>
             <a:endParaRPr lang="en-US" sz="1400" dirty="0"/>
           </a:p>
@@ -27638,7 +27638,7 @@
                 <a:ea typeface="Arial" pitchFamily="34" charset="-122"/>
                 <a:cs typeface="Arial" pitchFamily="34" charset="-120"/>
               </a:rPr>
-              <a:t>GitHub, access, and delivery</a:t>
+              <a:t>Share the work</a:t>
             </a:r>
             <a:endParaRPr lang="en-US" sz="2400" dirty="0"/>
           </a:p>
@@ -27838,7 +27838,7 @@
                 <a:ea typeface="Arial" pitchFamily="34" charset="-122"/>
                 <a:cs typeface="Arial" pitchFamily="34" charset="-120"/>
               </a:rPr>
-              <a:t>A prototype is not delivered while it lives only on your Mac.</a:t>
+              <a:t>Move it from your Mac to links others can open.</a:t>
             </a:r>
             <a:endParaRPr lang="en-US" sz="3100" dirty="0"/>
           </a:p>
@@ -27949,7 +27949,7 @@
                 <a:ea typeface="Arial" pitchFamily="34" charset="-122"/>
                 <a:cs typeface="Arial" pitchFamily="34" charset="-120"/>
               </a:rPr>
-              <a:t>Their GitHub account</a:t>
+              <a:t>Use your GitHub account</a:t>
             </a:r>
             <a:endParaRPr lang="en-US" sz="1390" dirty="0"/>
           </a:p>
@@ -28060,7 +28060,7 @@
                 <a:ea typeface="Arial" pitchFamily="34" charset="-122"/>
                 <a:cs typeface="Arial" pitchFamily="34" charset="-120"/>
               </a:rPr>
-              <a:t>Create repository</a:t>
+              <a:t>Create a repository</a:t>
             </a:r>
             <a:endParaRPr lang="en-US" sz="1390" dirty="0"/>
           </a:p>
@@ -28171,7 +28171,7 @@
                 <a:ea typeface="Arial" pitchFamily="34" charset="-122"/>
                 <a:cs typeface="Arial" pitchFamily="34" charset="-120"/>
               </a:rPr>
-              <a:t>Commit a named snapshot</a:t>
+              <a:t>Save a named version</a:t>
             </a:r>
             <a:endParaRPr lang="en-US" sz="1390" dirty="0"/>
           </a:p>
@@ -28282,7 +28282,7 @@
                 <a:ea typeface="Arial" pitchFamily="34" charset="-122"/>
                 <a:cs typeface="Arial" pitchFamily="34" charset="-120"/>
               </a:rPr>
-              <a:t>Publish</a:t>
+              <a:t>Publish it</a:t>
             </a:r>
             <a:endParaRPr lang="en-US" sz="1390" dirty="0"/>
           </a:p>
@@ -28393,7 +28393,7 @@
                 <a:ea typeface="Arial" pitchFamily="34" charset="-122"/>
                 <a:cs typeface="Arial" pitchFamily="34" charset="-120"/>
               </a:rPr>
-              <a:t>Deploy live preview</a:t>
+              <a:t>Create a live preview</a:t>
             </a:r>
             <a:endParaRPr lang="en-US" sz="1390" dirty="0"/>
           </a:p>
@@ -28504,7 +28504,7 @@
                 <a:ea typeface="Arial" pitchFamily="34" charset="-122"/>
                 <a:cs typeface="Arial" pitchFamily="34" charset="-120"/>
               </a:rPr>
-              <a:t>Share links</a:t>
+              <a:t>Share both links</a:t>
             </a:r>
             <a:endParaRPr lang="en-US" sz="1390" dirty="0"/>
           </a:p>
@@ -28545,7 +28545,7 @@
                 <a:ea typeface="Arial" pitchFamily="34" charset="-122"/>
                 <a:cs typeface="Arial" pitchFamily="34" charset="-120"/>
               </a:rPr>
-              <a:t>The Modus AI PDLC Playbook documents the path through Netlify deployment.</a:t>
+              <a:t>The Modus AI PDLC Playbook includes a Netlify deployment flow.</a:t>
             </a:r>
             <a:endParaRPr lang="en-US" sz="1400" dirty="0"/>
           </a:p>
@@ -28704,7 +28704,7 @@
                 <a:ea typeface="Arial" pitchFamily="34" charset="-122"/>
                 <a:cs typeface="Arial" pitchFamily="34" charset="-120"/>
               </a:rPr>
-              <a:t>Teach access—not secrets.</a:t>
+              <a:t>Share access, not credentials.</a:t>
             </a:r>
             <a:endParaRPr lang="en-US" sz="3100" dirty="0"/>
           </a:p>
@@ -28803,7 +28803,7 @@
                 <a:ea typeface="Arial" pitchFamily="34" charset="-122"/>
                 <a:cs typeface="Arial" pitchFamily="34" charset="-120"/>
               </a:rPr>
-              <a:t>Teach</a:t>
+              <a:t>What to share</a:t>
             </a:r>
             <a:endParaRPr lang="en-US" sz="2000" dirty="0"/>
           </a:p>
@@ -28844,7 +28844,7 @@
                 <a:ea typeface="Arial" pitchFamily="34" charset="-122"/>
                 <a:cs typeface="Arial" pitchFamily="34" charset="-120"/>
               </a:rPr>
-              <a:t>Do not teach</a:t>
+              <a:t>What stays private</a:t>
             </a:r>
             <a:endParaRPr lang="en-US" sz="2000" dirty="0"/>
           </a:p>
@@ -29823,7 +29823,7 @@
                 <a:ea typeface="Arial" pitchFamily="34" charset="-122"/>
                 <a:cs typeface="Arial" pitchFamily="34" charset="-120"/>
               </a:rPr>
-              <a:t>Phase 5 assessment</a:t>
+              <a:t>Delivery check</a:t>
             </a:r>
             <a:endParaRPr lang="en-US" sz="3100" dirty="0"/>
           </a:p>
@@ -29934,7 +29934,7 @@
                 <a:ea typeface="Arial" pitchFamily="34" charset="-122"/>
                 <a:cs typeface="Arial" pitchFamily="34" charset="-120"/>
               </a:rPr>
-              <a:t>Repo is under their GitHub account</a:t>
+              <a:t>The repository is in your GitHub account</a:t>
             </a:r>
             <a:endParaRPr lang="en-US" sz="1450" dirty="0"/>
           </a:p>
@@ -30045,7 +30045,7 @@
                 <a:ea typeface="Arial" pitchFamily="34" charset="-122"/>
                 <a:cs typeface="Arial" pitchFamily="34" charset="-120"/>
               </a:rPr>
-              <a:t>A named commit exists</a:t>
+              <a:t>There is a clearly named saved version</a:t>
             </a:r>
             <a:endParaRPr lang="en-US" sz="1450" dirty="0"/>
           </a:p>
@@ -30156,7 +30156,7 @@
                 <a:ea typeface="Arial" pitchFamily="34" charset="-122"/>
                 <a:cs typeface="Arial" pitchFamily="34" charset="-120"/>
               </a:rPr>
-              <a:t>Live URL opens for another person</a:t>
+              <a:t>Another person can open the live URL</a:t>
             </a:r>
             <a:endParaRPr lang="en-US" sz="1450" dirty="0"/>
           </a:p>
@@ -30267,7 +30267,7 @@
                 <a:ea typeface="Arial" pitchFamily="34" charset="-122"/>
                 <a:cs typeface="Arial" pitchFamily="34" charset="-120"/>
               </a:rPr>
-              <a:t>Collaborator access is added or demonstrated</a:t>
+              <a:t>You added or demonstrated collaborator access</a:t>
             </a:r>
             <a:endParaRPr lang="en-US" sz="1450" dirty="0"/>
           </a:p>
@@ -30378,7 +30378,7 @@
                 <a:ea typeface="Arial" pitchFamily="34" charset="-122"/>
                 <a:cs typeface="Arial" pitchFamily="34" charset="-120"/>
               </a:rPr>
-              <a:t>Figma + repo + preview links are recorded</a:t>
+              <a:t>The Figma, repository, and preview links are recorded</a:t>
             </a:r>
             <a:endParaRPr lang="en-US" sz="1450" dirty="0"/>
           </a:p>
@@ -30489,7 +30489,7 @@
                 <a:ea typeface="Arial" pitchFamily="34" charset="-122"/>
                 <a:cs typeface="Arial" pitchFamily="34" charset="-120"/>
               </a:rPr>
-              <a:t>Known limitations are documented</a:t>
+              <a:t>You wrote down what is not finished</a:t>
             </a:r>
             <a:endParaRPr lang="en-US" sz="1450" dirty="0"/>
           </a:p>
@@ -30530,7 +30530,7 @@
                 <a:ea typeface="Arial" pitchFamily="34" charset="-122"/>
                 <a:cs typeface="Arial" pitchFamily="34" charset="-120"/>
               </a:rPr>
-              <a:t>Delivery gate: another person can access and understand the work</a:t>
+              <a:t>Another person should be able to open the work and understand its status</a:t>
             </a:r>
             <a:endParaRPr lang="en-US" sz="1400" dirty="0"/>
           </a:p>
@@ -30689,7 +30689,7 @@
                 <a:ea typeface="Arial" pitchFamily="34" charset="-122"/>
                 <a:cs typeface="Arial" pitchFamily="34" charset="-120"/>
               </a:rPr>
-              <a:t>Final quality rubric</a:t>
+              <a:t>How we’ll review the final result</a:t>
             </a:r>
             <a:endParaRPr lang="en-US" sz="3100" dirty="0"/>
           </a:p>
@@ -31430,7 +31430,7 @@
                 <a:ea typeface="Arial" pitchFamily="34" charset="-122"/>
                 <a:cs typeface="Arial" pitchFamily="34" charset="-120"/>
               </a:rPr>
-              <a:t>0–3 each. Require at least 2 in states, accessibility, safety, and handoff.</a:t>
+              <a:t>We’ll score each area from 0–3. States, accessibility, safety, and handoff must each reach at least 2.</a:t>
             </a:r>
             <a:endParaRPr lang="en-US" sz="1400" dirty="0"/>
           </a:p>
@@ -31589,7 +31589,7 @@
                 <a:ea typeface="Arial" pitchFamily="34" charset="-122"/>
                 <a:cs typeface="Arial" pitchFamily="34" charset="-120"/>
               </a:rPr>
-              <a:t>Three-minute final showcase</a:t>
+              <a:t>Three minutes to show the work</a:t>
             </a:r>
             <a:endParaRPr lang="en-US" sz="3100" dirty="0"/>
           </a:p>
@@ -31659,7 +31659,7 @@
                 <a:ea typeface="Arial" pitchFamily="34" charset="-122"/>
                 <a:cs typeface="Arial" pitchFamily="34" charset="-120"/>
               </a:rPr>
-              <a:t>User problem</a:t>
+              <a:t>The user problem</a:t>
             </a:r>
             <a:endParaRPr lang="en-US" sz="1800" dirty="0"/>
           </a:p>
@@ -31729,7 +31729,7 @@
                 <a:ea typeface="Arial" pitchFamily="34" charset="-122"/>
                 <a:cs typeface="Arial" pitchFamily="34" charset="-120"/>
               </a:rPr>
-              <a:t>Interaction and states</a:t>
+              <a:t>The interaction and its states</a:t>
             </a:r>
             <a:endParaRPr lang="en-US" sz="1800" dirty="0"/>
           </a:p>
@@ -31799,7 +31799,7 @@
                 <a:ea typeface="Arial" pitchFamily="34" charset="-122"/>
                 <a:cs typeface="Arial" pitchFamily="34" charset="-120"/>
               </a:rPr>
-              <a:t>Brain inputs used</a:t>
+              <a:t>The context and tools you connected</a:t>
             </a:r>
             <a:endParaRPr lang="en-US" sz="1800" dirty="0"/>
           </a:p>
@@ -31869,7 +31869,7 @@
                 <a:ea typeface="Arial" pitchFamily="34" charset="-122"/>
                 <a:cs typeface="Arial" pitchFamily="34" charset="-120"/>
               </a:rPr>
-              <a:t>Live URL + repo</a:t>
+              <a:t>The live URL and repository</a:t>
             </a:r>
             <a:endParaRPr lang="en-US" sz="1800" dirty="0"/>
           </a:p>
@@ -31939,7 +31939,7 @@
                 <a:ea typeface="Arial" pitchFamily="34" charset="-122"/>
                 <a:cs typeface="Arial" pitchFamily="34" charset="-120"/>
               </a:rPr>
-              <a:t>One AI failure and repair</a:t>
+              <a:t>One Agent mistake and how you fixed it</a:t>
             </a:r>
             <a:endParaRPr lang="en-US" sz="1800" dirty="0"/>
           </a:p>
@@ -32009,7 +32009,7 @@
                 <a:ea typeface="Arial" pitchFamily="34" charset="-122"/>
                 <a:cs typeface="Arial" pitchFamily="34" charset="-120"/>
               </a:rPr>
-              <a:t>One judgment AI could not make</a:t>
+              <a:t>One decision you had to make yourself</a:t>
             </a:r>
             <a:endParaRPr lang="en-US" sz="1800" dirty="0"/>
           </a:p>
@@ -32168,7 +32168,7 @@
                 <a:ea typeface="Arial" pitchFamily="34" charset="-122"/>
                 <a:cs typeface="Arial" pitchFamily="34" charset="-120"/>
               </a:rPr>
-              <a:t>Two days, five phases</a:t>
+              <a:t>Here’s where we’re going.</a:t>
             </a:r>
             <a:endParaRPr lang="en-US" sz="3100" dirty="0"/>
           </a:p>
@@ -32501,7 +32501,7 @@
                 <a:ea typeface="Arial" pitchFamily="34" charset="-122"/>
                 <a:cs typeface="Arial" pitchFamily="34" charset="-120"/>
               </a:rPr>
-              <a:t>Cursor and Modus brain</a:t>
+              <a:t>Give Agent the right context and tools</a:t>
             </a:r>
             <a:endParaRPr lang="en-US" sz="1250" dirty="0"/>
           </a:p>
@@ -32612,7 +32612,7 @@
                 <a:ea typeface="Arial" pitchFamily="34" charset="-122"/>
                 <a:cs typeface="Arial" pitchFamily="34" charset="-120"/>
               </a:rPr>
-              <a:t>Production-quality Modus</a:t>
+              <a:t>Build the Modus version</a:t>
             </a:r>
             <a:endParaRPr lang="en-US" sz="1250" dirty="0"/>
           </a:p>
@@ -32882,7 +32882,7 @@
                 <a:ea typeface="Arial" pitchFamily="34" charset="-122"/>
                 <a:cs typeface="Arial" pitchFamily="34" charset="-120"/>
               </a:rPr>
-              <a:t>The workshop is the start—not the finish.</a:t>
+              <a:t>Keep using the workflow after the workshop.</a:t>
             </a:r>
             <a:endParaRPr lang="en-US" sz="3100" dirty="0"/>
           </a:p>
@@ -33485,7 +33485,7 @@
                 <a:ea typeface="Arial" pitchFamily="34" charset="-122"/>
                 <a:cs typeface="Arial" pitchFamily="34" charset="-120"/>
               </a:rPr>
-              <a:t>English starts the work. Design judgment makes it good.</a:t>
+              <a:t>Start simple. Be specific. Check what changed.</a:t>
             </a:r>
             <a:endParaRPr lang="en-US" sz="3100" dirty="0"/>
           </a:p>
@@ -33526,7 +33526,7 @@
                 <a:ea typeface="Arial" pitchFamily="34" charset="-122"/>
                 <a:cs typeface="Arial" pitchFamily="34" charset="-120"/>
               </a:rPr>
-              <a:t>Frame. Generate. Inspect. Verify. Ship.</a:t>
+              <a:t>Describe it. Try it. Fix it. Check it again. Share it.</a:t>
             </a:r>
             <a:endParaRPr lang="en-US" sz="3800" dirty="0"/>
           </a:p>
@@ -33823,7 +33823,7 @@
                 <a:ea typeface="Arial" pitchFamily="34" charset="-122"/>
                 <a:cs typeface="Arial" pitchFamily="34" charset="-120"/>
               </a:rPr>
-              <a:t>AI, HTML, and CSS—without becoming a coder</a:t>
+              <a:t>Start with a simple page</a:t>
             </a:r>
             <a:endParaRPr lang="en-US" sz="2400" dirty="0"/>
           </a:p>
@@ -34023,7 +34023,7 @@
                 <a:ea typeface="Arial" pitchFamily="34" charset="-122"/>
                 <a:cs typeface="Arial" pitchFamily="34" charset="-120"/>
               </a:rPr>
-              <a:t>Agent is a design collaborator that can build.</a:t>
+              <a:t>Describe what you want. Then look at what came back.</a:t>
             </a:r>
             <a:endParaRPr lang="en-US" sz="3100" dirty="0"/>
           </a:p>
@@ -34064,7 +34064,7 @@
                 <a:ea typeface="Arial" pitchFamily="34" charset="-122"/>
                 <a:cs typeface="Arial" pitchFamily="34" charset="-120"/>
               </a:rPr>
-              <a:t>You describe an outcome. Agent creates and runs it.</a:t>
+              <a:t>Agent can build the first version. It still needs your direction.</a:t>
             </a:r>
             <a:endParaRPr lang="en-US" sz="3800" dirty="0"/>
           </a:p>
@@ -34105,7 +34105,7 @@
                 <a:ea typeface="Arial" pitchFamily="34" charset="-122"/>
                 <a:cs typeface="Arial" pitchFamily="34" charset="-120"/>
               </a:rPr>
-              <a:t>Your job is to look, judge, and ask for the next bounded change.</a:t>
+              <a:t>Look at the page, choose one thing to improve, and explain the change clearly.</a:t>
             </a:r>
             <a:endParaRPr lang="en-US" sz="1400" dirty="0"/>
           </a:p>
@@ -34264,7 +34264,7 @@
                 <a:ea typeface="Arial" pitchFamily="34" charset="-122"/>
                 <a:cs typeface="Arial" pitchFamily="34" charset="-120"/>
               </a:rPr>
-              <a:t>One workspace: Agent + Preview</a:t>
+              <a:t>Keep two things open: Agent and Preview.</a:t>
             </a:r>
             <a:endParaRPr lang="en-US" sz="3100" dirty="0"/>
           </a:p>
@@ -34363,7 +34363,7 @@
                 <a:ea typeface="Arial" pitchFamily="34" charset="-122"/>
                 <a:cs typeface="Arial" pitchFamily="34" charset="-120"/>
               </a:rPr>
-              <a:t>Use</a:t>
+              <a:t>Work here</a:t>
             </a:r>
             <a:endParaRPr lang="en-US" sz="2000" dirty="0"/>
           </a:p>
@@ -34404,7 +34404,7 @@
                 <a:ea typeface="Arial" pitchFamily="34" charset="-122"/>
                 <a:cs typeface="Arial" pitchFamily="34" charset="-120"/>
               </a:rPr>
-              <a:t>Ignore</a:t>
+              <a:t>We won’t use</a:t>
             </a:r>
             <a:endParaRPr lang="en-US" sz="2000" dirty="0"/>
           </a:p>
@@ -34568,7 +34568,7 @@
                 <a:ea typeface="Arial" pitchFamily="34" charset="-122"/>
                 <a:cs typeface="Arial" pitchFamily="34" charset="-120"/>
               </a:rPr>
-              <a:t>English prompts</a:t>
+              <a:t>Natural-language requests</a:t>
             </a:r>
             <a:endParaRPr lang="en-US" sz="1550" dirty="0"/>
           </a:p>
@@ -34814,7 +34814,7 @@
                 <a:ea typeface="Arial" pitchFamily="34" charset="-122"/>
                 <a:cs typeface="Arial" pitchFamily="34" charset="-120"/>
               </a:rPr>
-              <a:t>Checkpoints to undo</a:t>
+              <a:t>Checkpoints when you want to undo</a:t>
             </a:r>
             <a:endParaRPr lang="en-US" sz="1550" dirty="0"/>
           </a:p>
@@ -35383,7 +35383,7 @@
                 <a:ea typeface="Arial" pitchFamily="34" charset="-122"/>
                 <a:cs typeface="Arial" pitchFamily="34" charset="-120"/>
               </a:rPr>
-              <a:t>HTML gives a page structure.</a:t>
+              <a:t>First, Agent needs to organize the page.</a:t>
             </a:r>
             <a:endParaRPr lang="en-US" sz="3100" dirty="0"/>
           </a:p>
@@ -35536,7 +35536,7 @@
                 <a:ea typeface="Arial" pitchFamily="34" charset="-122"/>
                 <a:cs typeface="Arial" pitchFamily="34" charset="-120"/>
               </a:rPr>
-              <a:t>Think rooms in a building: regions exist, but they do not yet communicate a visual hierarchy.</a:t>
+              <a:t>At first, we only need the main areas: a heading, some controls, content, and actions.</a:t>
             </a:r>
             <a:endParaRPr lang="en-US" sz="1400" dirty="0"/>
           </a:p>

</xml_diff>